<commit_message>
v3 deck: domestic market framing
Slide 7 now shows Korea's statutory inspection cycles under the
Facility Safety Act instead of the U.S. Level I-III scheme. Slide 8 is
the nested-circle option: domestic facility inspection/diagnosis
market (KRW 519.2B, MOLIT), drone survey/inspection market
(KRW 166.7B, Drone Portal), and a 1% SOM target. Notes and the Word
script follow.

Co-Authored-By: Claude Opus 5.5 <noreply@anthropic.com>
Claude-Session: https://claude.ai/code/session_01WJhUeJknrpz3z9hRfyX3tP
</commit_message>
<xml_diff>
--- a/MLC_IR_A-STREAM2026_v3.pptx
+++ b/MLC_IR_A-STREAM2026_v3.pptx
@@ -1136,7 +1136,7 @@
           <a:p>
             <a:r>
               <a:rPr lang="en-US" dirty="0"/>
-              <a:t>이 시장은 규제가 반복 수요를 만듭니다. 미국 해양 플랫폼은 매년, 3~5년, 6~10년 주기로 점검이 의무입니다. 인터뷰에서 확인한 구매 동기는 안전, 비용, 규제와 보험 대응 세 가지였습니다. MLC는 그중 비용에서 바로 효과를 냅니다. 위험한 지점부터 배를 보내 선박 용선과 기상 대기 일수를 줄이고, 필요한 구간에만 리프트와 비계를 빌리고, 로프 액세스 팀을 보낼지 미리 판단하고, 점검 기록도 사진 리포트로 정리합니다.</a:t>
+              <a:t>이 시장은 법이 반복 수요를 만듭니다. 국내 「시설물안전법」에 따라 관리 대상 시설물 16만여 곳은 반기마다 정기안전점검, 1~3년마다 정밀안전점검을 받고, 제1종 시설물은 4~6년마다 정밀안전진단까지 받아야 합니다. 미국 현장 인터뷰에서 확인한 구매 동기는 안전, 비용, 규제 대응이었고, MLC는 그중 비용에서 바로 효과를 냅니다. 위험한 지점부터 배를 보내고, 필요한 구간에만 리프트와 비계를 빌리고, 로프 액세스 출동 여부를 미리 판단하고, 점검 기록도 사진 리포트로 정리합니다.</a:t>
             </a:r>
           </a:p>
         </p:txBody>
@@ -1223,13 +1223,13 @@
           <a:p>
             <a:r>
               <a:rPr lang="en-US" dirty="0"/>
-              <a:t>[약 30초]</a:t>
+              <a:t>[약 25초]</a:t>
             </a:r>
           </a:p>
           <a:p>
             <a:r>
               <a:rPr lang="en-US" dirty="0"/>
-              <a:t>시장 규모입니다. 전체 시장은 글로벌 해양 점검·보수·유지 시장으로 2024년 136억 달러, 연 8.4%씩 성장하고 있습니다. 그중 저희가 바로 들어갈 수 있는 해양 드론 점검 서비스 시장은 15억 달러로, 연 11.5%씩 더 빠르게 커지고 있습니다. 저희는 3년 안에 이 시장의 1%, 1,500만 달러를 목표로 하고, 첫 타깃은 매년 점검을 받아야 하는 멕시코만 유인 생산 플랫폼 371곳입니다.</a:t>
+              <a:t>시장 규모입니다. 국내 시설물 안전점검·진단 시장은 2021년 5,192억 원으로, 연 15%씩 성장해 왔습니다. 그중 드론 측량·점검·관측 시장이 1,667억 원이고, 저희는 3년 안에 이 시장의 1%, 17억 원을 목표로 합니다. 해양·항만 강구조물과 해상풍력부터 시작하겠습니다.</a:t>
             </a:r>
           </a:p>
         </p:txBody>
@@ -11421,7 +11421,6 @@
         <a:solidFill>
           <a:srgbClr val="FFFFFF"/>
         </a:solidFill>
-        <a:effectLst/>
       </p:bgPr>
     </p:bg>
     <p:spTree>
@@ -11459,11 +11458,11 @@
           <a:bodyPr wrap="square" lIns="0" tIns="0" rIns="0" bIns="0" rtlCol="0" anchor="t"/>
           <a:lstStyle/>
           <a:p>
-            <a:pPr marL="0" indent="0">
-              <a:buNone/>
-            </a:pPr>
-            <a:r>
-              <a:rPr lang="en-US" sz="1200" b="1" kern="0" spc="100" dirty="0">
+            <a:pPr indent="0" marL="0">
+              <a:buNone/>
+            </a:pPr>
+            <a:r>
+              <a:rPr lang="en-US" sz="1200" b="1" spc="100" kern="0" dirty="0">
                 <a:solidFill>
                   <a:srgbClr val="B5501F"/>
                 </a:solidFill>
@@ -11498,7 +11497,7 @@
           <a:bodyPr wrap="square" lIns="0" tIns="0" rIns="0" bIns="0" rtlCol="0" anchor="ctr"/>
           <a:lstStyle/>
           <a:p>
-            <a:pPr marL="0" indent="0">
+            <a:pPr indent="0" marL="0">
               <a:buNone/>
             </a:pPr>
             <a:r>
@@ -11537,7 +11536,7 @@
           <a:bodyPr wrap="square" lIns="0" tIns="0" rIns="0" bIns="0" rtlCol="0" anchor="t"/>
           <a:lstStyle/>
           <a:p>
-            <a:pPr marL="0" indent="0">
+            <a:pPr indent="0" marL="0">
               <a:buNone/>
             </a:pPr>
             <a:r>
@@ -11576,7 +11575,7 @@
           <a:bodyPr wrap="square" lIns="0" tIns="0" rIns="0" bIns="0" rtlCol="0" anchor="t"/>
           <a:lstStyle/>
           <a:p>
-            <a:pPr marL="0" indent="0" algn="r">
+            <a:pPr algn="r" indent="0" marL="0">
               <a:buNone/>
             </a:pPr>
             <a:r>
@@ -11642,7 +11641,7 @@
           <a:bodyPr wrap="square" lIns="0" tIns="0" rIns="0" bIns="0" rtlCol="0" anchor="t"/>
           <a:lstStyle/>
           <a:p>
-            <a:pPr marL="0" indent="0">
+            <a:pPr indent="0" marL="0">
               <a:buNone/>
             </a:pPr>
             <a:r>
@@ -11654,7 +11653,7 @@
                 <a:ea typeface="맑은 고딕" pitchFamily="34" charset="-122"/>
                 <a:cs typeface="맑은 고딕" pitchFamily="34" charset="-120"/>
               </a:rPr>
-              <a:t>Level I</a:t>
+              <a:t>정기안전점검</a:t>
             </a:r>
             <a:endParaRPr lang="en-US" sz="1400" dirty="0"/>
           </a:p>
@@ -11681,7 +11680,7 @@
           <a:bodyPr wrap="square" lIns="0" tIns="0" rIns="0" bIns="0" rtlCol="0" anchor="t"/>
           <a:lstStyle/>
           <a:p>
-            <a:pPr marL="0" indent="0" algn="r">
+            <a:pPr algn="r" indent="0" marL="0">
               <a:buNone/>
             </a:pPr>
             <a:r>
@@ -11693,7 +11692,7 @@
                 <a:ea typeface="맑은 고딕" pitchFamily="34" charset="-122"/>
                 <a:cs typeface="맑은 고딕" pitchFamily="34" charset="-120"/>
               </a:rPr>
-              <a:t>매년</a:t>
+              <a:t>반기 1회</a:t>
             </a:r>
             <a:endParaRPr lang="en-US" sz="2200" dirty="0"/>
           </a:p>
@@ -11720,7 +11719,7 @@
           <a:bodyPr wrap="square" lIns="0" tIns="0" rIns="0" bIns="0" rtlCol="0" anchor="t"/>
           <a:lstStyle/>
           <a:p>
-            <a:pPr marL="0" indent="0">
+            <a:pPr indent="0" marL="0">
               <a:buNone/>
             </a:pPr>
             <a:r>
@@ -11732,7 +11731,7 @@
                 <a:ea typeface="맑은 고딕" pitchFamily="34" charset="-122"/>
                 <a:cs typeface="맑은 고딕" pitchFamily="34" charset="-120"/>
               </a:rPr>
-              <a:t>수상 육안 점검</a:t>
+              <a:t>육안 중심 상태 점검</a:t>
             </a:r>
             <a:endParaRPr lang="en-US" sz="1600" dirty="0"/>
           </a:p>
@@ -11759,7 +11758,7 @@
           <a:bodyPr wrap="square" lIns="0" tIns="0" rIns="0" bIns="0" rtlCol="0" anchor="t"/>
           <a:lstStyle/>
           <a:p>
-            <a:pPr marL="0" indent="0">
+            <a:pPr indent="0" marL="0">
               <a:buNone/>
             </a:pPr>
             <a:r>
@@ -11771,7 +11770,7 @@
                 <a:ea typeface="맑은 고딕" pitchFamily="34" charset="-122"/>
                 <a:cs typeface="맑은 고딕" pitchFamily="34" charset="-120"/>
               </a:rPr>
-              <a:t>도장 · 구조 · 비말대 육안 스캔</a:t>
+              <a:t>A · B · C등급 기준</a:t>
             </a:r>
             <a:endParaRPr lang="en-US" sz="1250" dirty="0"/>
           </a:p>
@@ -11825,7 +11824,7 @@
           <a:bodyPr wrap="square" lIns="0" tIns="0" rIns="0" bIns="0" rtlCol="0" anchor="t"/>
           <a:lstStyle/>
           <a:p>
-            <a:pPr marL="0" indent="0">
+            <a:pPr indent="0" marL="0">
               <a:buNone/>
             </a:pPr>
             <a:r>
@@ -11837,7 +11836,7 @@
                 <a:ea typeface="맑은 고딕" pitchFamily="34" charset="-122"/>
                 <a:cs typeface="맑은 고딕" pitchFamily="34" charset="-120"/>
               </a:rPr>
-              <a:t>Level II</a:t>
+              <a:t>정밀안전점검</a:t>
             </a:r>
             <a:endParaRPr lang="en-US" sz="1400" dirty="0"/>
           </a:p>
@@ -11864,7 +11863,7 @@
           <a:bodyPr wrap="square" lIns="0" tIns="0" rIns="0" bIns="0" rtlCol="0" anchor="t"/>
           <a:lstStyle/>
           <a:p>
-            <a:pPr marL="0" indent="0" algn="r">
+            <a:pPr algn="r" indent="0" marL="0">
               <a:buNone/>
             </a:pPr>
             <a:r>
@@ -11876,7 +11875,7 @@
                 <a:ea typeface="맑은 고딕" pitchFamily="34" charset="-122"/>
                 <a:cs typeface="맑은 고딕" pitchFamily="34" charset="-120"/>
               </a:rPr>
-              <a:t>3–5년</a:t>
+              <a:t>1–3년</a:t>
             </a:r>
             <a:endParaRPr lang="en-US" sz="2200" dirty="0"/>
           </a:p>
@@ -11903,7 +11902,7 @@
           <a:bodyPr wrap="square" lIns="0" tIns="0" rIns="0" bIns="0" rtlCol="0" anchor="t"/>
           <a:lstStyle/>
           <a:p>
-            <a:pPr marL="0" indent="0">
+            <a:pPr indent="0" marL="0">
               <a:buNone/>
             </a:pPr>
             <a:r>
@@ -11915,7 +11914,7 @@
                 <a:ea typeface="맑은 고딕" pitchFamily="34" charset="-122"/>
                 <a:cs typeface="맑은 고딕" pitchFamily="34" charset="-120"/>
               </a:rPr>
-              <a:t>수중 일반 점검</a:t>
+              <a:t>근접 육안 · 측정 장비 점검</a:t>
             </a:r>
             <a:endParaRPr lang="en-US" sz="1600" dirty="0"/>
           </a:p>
@@ -11942,7 +11941,7 @@
           <a:bodyPr wrap="square" lIns="0" tIns="0" rIns="0" bIns="0" rtlCol="0" anchor="t"/>
           <a:lstStyle/>
           <a:p>
-            <a:pPr marL="0" indent="0">
+            <a:pPr indent="0" marL="0">
               <a:buNone/>
             </a:pPr>
             <a:r>
@@ -11954,7 +11953,7 @@
                 <a:ea typeface="맑은 고딕" pitchFamily="34" charset="-122"/>
                 <a:cs typeface="맑은 고딕" pitchFamily="34" charset="-120"/>
               </a:rPr>
-              <a:t>잠수부 · ROV 조사</a:t>
+              <a:t>건축물 외 시설물 · 등급별</a:t>
             </a:r>
             <a:endParaRPr lang="en-US" sz="1250" dirty="0"/>
           </a:p>
@@ -12008,7 +12007,7 @@
           <a:bodyPr wrap="square" lIns="0" tIns="0" rIns="0" bIns="0" rtlCol="0" anchor="t"/>
           <a:lstStyle/>
           <a:p>
-            <a:pPr marL="0" indent="0">
+            <a:pPr indent="0" marL="0">
               <a:buNone/>
             </a:pPr>
             <a:r>
@@ -12020,7 +12019,7 @@
                 <a:ea typeface="맑은 고딕" pitchFamily="34" charset="-122"/>
                 <a:cs typeface="맑은 고딕" pitchFamily="34" charset="-120"/>
               </a:rPr>
-              <a:t>Level III</a:t>
+              <a:t>정밀안전진단</a:t>
             </a:r>
             <a:endParaRPr lang="en-US" sz="1400" dirty="0"/>
           </a:p>
@@ -12047,7 +12046,7 @@
           <a:bodyPr wrap="square" lIns="0" tIns="0" rIns="0" bIns="0" rtlCol="0" anchor="t"/>
           <a:lstStyle/>
           <a:p>
-            <a:pPr marL="0" indent="0" algn="r">
+            <a:pPr algn="r" indent="0" marL="0">
               <a:buNone/>
             </a:pPr>
             <a:r>
@@ -12059,7 +12058,7 @@
                 <a:ea typeface="맑은 고딕" pitchFamily="34" charset="-122"/>
                 <a:cs typeface="맑은 고딕" pitchFamily="34" charset="-120"/>
               </a:rPr>
-              <a:t>6–10년</a:t>
+              <a:t>4–6년</a:t>
             </a:r>
             <a:endParaRPr lang="en-US" sz="2200" dirty="0"/>
           </a:p>
@@ -12086,7 +12085,7 @@
           <a:bodyPr wrap="square" lIns="0" tIns="0" rIns="0" bIns="0" rtlCol="0" anchor="t"/>
           <a:lstStyle/>
           <a:p>
-            <a:pPr marL="0" indent="0">
+            <a:pPr indent="0" marL="0">
               <a:buNone/>
             </a:pPr>
             <a:r>
@@ -12098,7 +12097,7 @@
                 <a:ea typeface="맑은 고딕" pitchFamily="34" charset="-122"/>
                 <a:cs typeface="맑은 고딕" pitchFamily="34" charset="-120"/>
               </a:rPr>
-              <a:t>수중 정밀 점검</a:t>
+              <a:t>재료 시험 · 구조 안전성 평가</a:t>
             </a:r>
             <a:endParaRPr lang="en-US" sz="1600" dirty="0"/>
           </a:p>
@@ -12125,7 +12124,7 @@
           <a:bodyPr wrap="square" lIns="0" tIns="0" rIns="0" bIns="0" rtlCol="0" anchor="t"/>
           <a:lstStyle/>
           <a:p>
-            <a:pPr marL="0" indent="0">
+            <a:pPr indent="0" marL="0">
               <a:buNone/>
             </a:pPr>
             <a:r>
@@ -12137,7 +12136,7 @@
                 <a:ea typeface="맑은 고딕" pitchFamily="34" charset="-122"/>
                 <a:cs typeface="맑은 고딕" pitchFamily="34" charset="-120"/>
               </a:rPr>
-              <a:t>지정 부위 세척 후 근접 육안 · 피트 계측</a:t>
+              <a:t>제1종 시설물 · 등급별</a:t>
             </a:r>
             <a:endParaRPr lang="en-US" sz="1250" dirty="0"/>
           </a:p>
@@ -12145,7 +12144,244 @@
       </p:sp>
       <p:sp>
         <p:nvSpPr>
-          <p:cNvPr id="30" name="Shape 28"/>
+          <p:cNvPr id="21" name="Text 19"/>
+          <p:cNvSpPr txBox="1"/>
+          <p:nvPr/>
+        </p:nvSpPr>
+        <p:spPr>
+          <a:xfrm>
+            <a:off x="548640" y="3127248"/>
+            <a:ext cx="6949440" cy="274320"/>
+          </a:xfrm>
+          <a:prstGeom prst="rect">
+            <a:avLst/>
+          </a:prstGeom>
+          <a:noFill/>
+          <a:ln/>
+        </p:spPr>
+        <p:txBody>
+          <a:bodyPr wrap="square" lIns="0" tIns="0" rIns="0" bIns="0" rtlCol="0" anchor="t"/>
+          <a:lstStyle/>
+          <a:p>
+            <a:pPr indent="0" marL="0">
+              <a:buNone/>
+            </a:pPr>
+            <a:r>
+              <a:rPr lang="en-US" sz="1200" dirty="0">
+                <a:solidFill>
+                  <a:srgbClr val="6B6F76"/>
+                </a:solidFill>
+                <a:latin typeface="맑은 고딕" pitchFamily="34" charset="0"/>
+                <a:ea typeface="맑은 고딕" pitchFamily="34" charset="-122"/>
+                <a:cs typeface="맑은 고딕" pitchFamily="34" charset="-120"/>
+              </a:rPr>
+              <a:t>국내 「시설물안전법」 점검 체계 — 법적 관리 대상 162,481개소 ('22.6, 국토교통부)</a:t>
+            </a:r>
+            <a:endParaRPr lang="en-US" sz="1200" dirty="0"/>
+          </a:p>
+        </p:txBody>
+      </p:sp>
+      <p:sp>
+        <p:nvSpPr>
+          <p:cNvPr id="22" name="Shape 20"/>
+          <p:cNvSpPr/>
+          <p:nvPr/>
+        </p:nvSpPr>
+        <p:spPr>
+          <a:xfrm>
+            <a:off x="7482535" y="3108960"/>
+            <a:ext cx="1234440" cy="310896"/>
+          </a:xfrm>
+          <a:prstGeom prst="roundRect">
+            <a:avLst>
+              <a:gd name="adj" fmla="val 50000"/>
+            </a:avLst>
+          </a:prstGeom>
+          <a:solidFill>
+            <a:srgbClr val="1F5F7A"/>
+          </a:solidFill>
+          <a:ln w="12700">
+            <a:solidFill>
+              <a:srgbClr val="1F5F7A"/>
+            </a:solidFill>
+            <a:prstDash val="solid"/>
+          </a:ln>
+        </p:spPr>
+      </p:sp>
+      <p:sp>
+        <p:nvSpPr>
+          <p:cNvPr id="23" name="Text 21"/>
+          <p:cNvSpPr txBox="1"/>
+          <p:nvPr/>
+        </p:nvSpPr>
+        <p:spPr>
+          <a:xfrm>
+            <a:off x="7482535" y="3108960"/>
+            <a:ext cx="1234440" cy="310896"/>
+          </a:xfrm>
+          <a:prstGeom prst="rect">
+            <a:avLst/>
+          </a:prstGeom>
+          <a:noFill/>
+          <a:ln/>
+        </p:spPr>
+        <p:txBody>
+          <a:bodyPr wrap="square" lIns="0" tIns="0" rIns="0" bIns="0" rtlCol="0" anchor="ctr"/>
+          <a:lstStyle/>
+          <a:p>
+            <a:pPr algn="ctr" indent="0" marL="0">
+              <a:buNone/>
+            </a:pPr>
+            <a:r>
+              <a:rPr lang="en-US" sz="1100" b="1" dirty="0">
+                <a:solidFill>
+                  <a:srgbClr val="FFFFFF"/>
+                </a:solidFill>
+                <a:latin typeface="맑은 고딕" pitchFamily="34" charset="0"/>
+                <a:ea typeface="맑은 고딕" pitchFamily="34" charset="-122"/>
+                <a:cs typeface="맑은 고딕" pitchFamily="34" charset="-120"/>
+              </a:rPr>
+              <a:t>국토교통부</a:t>
+            </a:r>
+            <a:endParaRPr lang="en-US" sz="1100" dirty="0"/>
+          </a:p>
+        </p:txBody>
+      </p:sp>
+      <p:sp>
+        <p:nvSpPr>
+          <p:cNvPr id="24" name="Shape 22"/>
+          <p:cNvSpPr/>
+          <p:nvPr/>
+        </p:nvSpPr>
+        <p:spPr>
+          <a:xfrm>
+            <a:off x="8808415" y="3108960"/>
+            <a:ext cx="1234440" cy="310896"/>
+          </a:xfrm>
+          <a:prstGeom prst="roundRect">
+            <a:avLst>
+              <a:gd name="adj" fmla="val 50000"/>
+            </a:avLst>
+          </a:prstGeom>
+          <a:solidFill>
+            <a:srgbClr val="1F5F7A"/>
+          </a:solidFill>
+          <a:ln w="12700">
+            <a:solidFill>
+              <a:srgbClr val="1F5F7A"/>
+            </a:solidFill>
+            <a:prstDash val="solid"/>
+          </a:ln>
+        </p:spPr>
+      </p:sp>
+      <p:sp>
+        <p:nvSpPr>
+          <p:cNvPr id="25" name="Text 23"/>
+          <p:cNvSpPr txBox="1"/>
+          <p:nvPr/>
+        </p:nvSpPr>
+        <p:spPr>
+          <a:xfrm>
+            <a:off x="8808415" y="3108960"/>
+            <a:ext cx="1234440" cy="310896"/>
+          </a:xfrm>
+          <a:prstGeom prst="rect">
+            <a:avLst/>
+          </a:prstGeom>
+          <a:noFill/>
+          <a:ln/>
+        </p:spPr>
+        <p:txBody>
+          <a:bodyPr wrap="square" lIns="0" tIns="0" rIns="0" bIns="0" rtlCol="0" anchor="ctr"/>
+          <a:lstStyle/>
+          <a:p>
+            <a:pPr algn="ctr" indent="0" marL="0">
+              <a:buNone/>
+            </a:pPr>
+            <a:r>
+              <a:rPr lang="en-US" sz="1100" b="1" dirty="0">
+                <a:solidFill>
+                  <a:srgbClr val="FFFFFF"/>
+                </a:solidFill>
+                <a:latin typeface="맑은 고딕" pitchFamily="34" charset="0"/>
+                <a:ea typeface="맑은 고딕" pitchFamily="34" charset="-122"/>
+                <a:cs typeface="맑은 고딕" pitchFamily="34" charset="-120"/>
+              </a:rPr>
+              <a:t>해양수산부</a:t>
+            </a:r>
+            <a:endParaRPr lang="en-US" sz="1100" dirty="0"/>
+          </a:p>
+        </p:txBody>
+      </p:sp>
+      <p:sp>
+        <p:nvSpPr>
+          <p:cNvPr id="26" name="Shape 24"/>
+          <p:cNvSpPr/>
+          <p:nvPr/>
+        </p:nvSpPr>
+        <p:spPr>
+          <a:xfrm>
+            <a:off x="10134295" y="3108960"/>
+            <a:ext cx="1508760" cy="310896"/>
+          </a:xfrm>
+          <a:prstGeom prst="roundRect">
+            <a:avLst>
+              <a:gd name="adj" fmla="val 50000"/>
+            </a:avLst>
+          </a:prstGeom>
+          <a:solidFill>
+            <a:srgbClr val="1F5F7A"/>
+          </a:solidFill>
+          <a:ln w="12700">
+            <a:solidFill>
+              <a:srgbClr val="1F5F7A"/>
+            </a:solidFill>
+            <a:prstDash val="solid"/>
+          </a:ln>
+        </p:spPr>
+      </p:sp>
+      <p:sp>
+        <p:nvSpPr>
+          <p:cNvPr id="27" name="Text 25"/>
+          <p:cNvSpPr txBox="1"/>
+          <p:nvPr/>
+        </p:nvSpPr>
+        <p:spPr>
+          <a:xfrm>
+            <a:off x="10134295" y="3108960"/>
+            <a:ext cx="1508760" cy="310896"/>
+          </a:xfrm>
+          <a:prstGeom prst="rect">
+            <a:avLst/>
+          </a:prstGeom>
+          <a:noFill/>
+          <a:ln/>
+        </p:spPr>
+        <p:txBody>
+          <a:bodyPr wrap="square" lIns="0" tIns="0" rIns="0" bIns="0" rtlCol="0" anchor="ctr"/>
+          <a:lstStyle/>
+          <a:p>
+            <a:pPr algn="ctr" indent="0" marL="0">
+              <a:buNone/>
+            </a:pPr>
+            <a:r>
+              <a:rPr lang="en-US" sz="1100" b="1" dirty="0">
+                <a:solidFill>
+                  <a:srgbClr val="FFFFFF"/>
+                </a:solidFill>
+                <a:latin typeface="맑은 고딕" pitchFamily="34" charset="0"/>
+                <a:ea typeface="맑은 고딕" pitchFamily="34" charset="-122"/>
+                <a:cs typeface="맑은 고딕" pitchFamily="34" charset="-120"/>
+              </a:rPr>
+              <a:t>국토안전관리원</a:t>
+            </a:r>
+            <a:endParaRPr lang="en-US" sz="1100" dirty="0"/>
+          </a:p>
+        </p:txBody>
+      </p:sp>
+      <p:sp>
+        <p:nvSpPr>
+          <p:cNvPr id="28" name="Shape 26"/>
           <p:cNvSpPr/>
           <p:nvPr/>
         </p:nvSpPr>
@@ -12172,7 +12408,7 @@
       </p:sp>
       <p:sp>
         <p:nvSpPr>
-          <p:cNvPr id="31" name="Text 29"/>
+          <p:cNvPr id="29" name="Text 27"/>
           <p:cNvSpPr txBox="1"/>
           <p:nvPr/>
         </p:nvSpPr>
@@ -12191,7 +12427,7 @@
           <a:bodyPr wrap="square" lIns="0" tIns="0" rIns="0" bIns="0" rtlCol="0" anchor="t"/>
           <a:lstStyle/>
           <a:p>
-            <a:pPr marL="0" indent="0">
+            <a:pPr indent="0" marL="0">
               <a:buNone/>
             </a:pPr>
             <a:r>
@@ -12211,7 +12447,7 @@
       </p:sp>
       <p:sp>
         <p:nvSpPr>
-          <p:cNvPr id="32" name="Shape 30"/>
+          <p:cNvPr id="30" name="Shape 28"/>
           <p:cNvSpPr/>
           <p:nvPr/>
         </p:nvSpPr>
@@ -12236,14 +12472,14 @@
       </p:sp>
       <p:pic>
         <p:nvPicPr>
-          <p:cNvPr id="33" name="Image 0" descr="preencoded.png"/>
+          <p:cNvPr id="31" name="Image 0" descr="preencoded.png">    </p:cNvPr>
           <p:cNvPicPr>
             <a:picLocks noChangeAspect="1"/>
           </p:cNvPicPr>
           <p:nvPr/>
         </p:nvPicPr>
         <p:blipFill>
-          <a:blip r:embed="rId3"/>
+          <a:blip r:embed="rId1"/>
           <a:stretch>
             <a:fillRect/>
           </a:stretch>
@@ -12260,7 +12496,7 @@
       </p:pic>
       <p:sp>
         <p:nvSpPr>
-          <p:cNvPr id="34" name="Text 31"/>
+          <p:cNvPr id="32" name="Text 29"/>
           <p:cNvSpPr txBox="1"/>
           <p:nvPr/>
         </p:nvSpPr>
@@ -12279,7 +12515,7 @@
           <a:bodyPr wrap="square" lIns="0" tIns="0" rIns="0" bIns="0" rtlCol="0" anchor="ctr"/>
           <a:lstStyle/>
           <a:p>
-            <a:pPr marL="0" indent="0">
+            <a:pPr indent="0" marL="0">
               <a:buNone/>
             </a:pPr>
             <a:r>
@@ -12293,6 +12529,9 @@
               </a:rPr>
               <a:t>안전   </a:t>
             </a:r>
+            <a:pPr indent="0" marL="0">
+              <a:buNone/>
+            </a:pPr>
             <a:r>
               <a:rPr lang="en-US" sz="1300" dirty="0">
                 <a:solidFill>
@@ -12310,7 +12549,7 @@
       </p:sp>
       <p:sp>
         <p:nvSpPr>
-          <p:cNvPr id="35" name="Shape 32"/>
+          <p:cNvPr id="33" name="Shape 30"/>
           <p:cNvSpPr/>
           <p:nvPr/>
         </p:nvSpPr>
@@ -12335,14 +12574,14 @@
       </p:sp>
       <p:pic>
         <p:nvPicPr>
-          <p:cNvPr id="36" name="Image 1" descr="preencoded.png"/>
+          <p:cNvPr id="34" name="Image 1" descr="preencoded.png">    </p:cNvPr>
           <p:cNvPicPr>
             <a:picLocks noChangeAspect="1"/>
           </p:cNvPicPr>
           <p:nvPr/>
         </p:nvPicPr>
         <p:blipFill>
-          <a:blip r:embed="rId4"/>
+          <a:blip r:embed="rId2"/>
           <a:stretch>
             <a:fillRect/>
           </a:stretch>
@@ -12359,7 +12598,7 @@
       </p:pic>
       <p:sp>
         <p:nvSpPr>
-          <p:cNvPr id="37" name="Text 33"/>
+          <p:cNvPr id="35" name="Text 31"/>
           <p:cNvSpPr txBox="1"/>
           <p:nvPr/>
         </p:nvSpPr>
@@ -12378,7 +12617,7 @@
           <a:bodyPr wrap="square" lIns="0" tIns="0" rIns="0" bIns="0" rtlCol="0" anchor="ctr"/>
           <a:lstStyle/>
           <a:p>
-            <a:pPr marL="0" indent="0">
+            <a:pPr indent="0" marL="0">
               <a:buNone/>
             </a:pPr>
             <a:r>
@@ -12392,6 +12631,9 @@
               </a:rPr>
               <a:t>비용   </a:t>
             </a:r>
+            <a:pPr indent="0" marL="0">
+              <a:buNone/>
+            </a:pPr>
             <a:r>
               <a:rPr lang="en-US" sz="1300" dirty="0">
                 <a:solidFill>
@@ -12409,7 +12651,7 @@
       </p:sp>
       <p:sp>
         <p:nvSpPr>
-          <p:cNvPr id="38" name="Shape 34"/>
+          <p:cNvPr id="36" name="Shape 32"/>
           <p:cNvSpPr/>
           <p:nvPr/>
         </p:nvSpPr>
@@ -12434,14 +12676,14 @@
       </p:sp>
       <p:pic>
         <p:nvPicPr>
-          <p:cNvPr id="39" name="Image 2" descr="preencoded.png"/>
+          <p:cNvPr id="37" name="Image 2" descr="preencoded.png">    </p:cNvPr>
           <p:cNvPicPr>
             <a:picLocks noChangeAspect="1"/>
           </p:cNvPicPr>
           <p:nvPr/>
         </p:nvPicPr>
         <p:blipFill>
-          <a:blip r:embed="rId5"/>
+          <a:blip r:embed="rId3"/>
           <a:stretch>
             <a:fillRect/>
           </a:stretch>
@@ -12458,7 +12700,7 @@
       </p:pic>
       <p:sp>
         <p:nvSpPr>
-          <p:cNvPr id="40" name="Text 35"/>
+          <p:cNvPr id="38" name="Text 33"/>
           <p:cNvSpPr txBox="1"/>
           <p:nvPr/>
         </p:nvSpPr>
@@ -12477,7 +12719,7 @@
           <a:bodyPr wrap="square" lIns="0" tIns="0" rIns="0" bIns="0" rtlCol="0" anchor="ctr"/>
           <a:lstStyle/>
           <a:p>
-            <a:pPr marL="0" indent="0">
+            <a:pPr indent="0" marL="0">
               <a:buNone/>
             </a:pPr>
             <a:r>
@@ -12491,6 +12733,9 @@
               </a:rPr>
               <a:t>규제 · 보험   </a:t>
             </a:r>
+            <a:pPr indent="0" marL="0">
+              <a:buNone/>
+            </a:pPr>
             <a:r>
               <a:rPr lang="en-US" sz="1300" dirty="0">
                 <a:solidFill>
@@ -12508,7 +12753,7 @@
       </p:sp>
       <p:sp>
         <p:nvSpPr>
-          <p:cNvPr id="41" name="Shape 36"/>
+          <p:cNvPr id="39" name="Shape 34"/>
           <p:cNvSpPr/>
           <p:nvPr/>
         </p:nvSpPr>
@@ -12535,7 +12780,7 @@
       </p:sp>
       <p:sp>
         <p:nvSpPr>
-          <p:cNvPr id="42" name="Text 37"/>
+          <p:cNvPr id="40" name="Text 35"/>
           <p:cNvSpPr txBox="1"/>
           <p:nvPr/>
         </p:nvSpPr>
@@ -12554,7 +12799,7 @@
           <a:bodyPr wrap="square" lIns="0" tIns="0" rIns="0" bIns="0" rtlCol="0" anchor="t"/>
           <a:lstStyle/>
           <a:p>
-            <a:pPr marL="0" indent="0">
+            <a:pPr indent="0" marL="0">
               <a:buNone/>
             </a:pPr>
             <a:r>
@@ -12574,7 +12819,7 @@
       </p:sp>
       <p:sp>
         <p:nvSpPr>
-          <p:cNvPr id="43" name="Shape 38"/>
+          <p:cNvPr id="41" name="Shape 36"/>
           <p:cNvSpPr/>
           <p:nvPr/>
         </p:nvSpPr>
@@ -12599,14 +12844,14 @@
       </p:sp>
       <p:pic>
         <p:nvPicPr>
-          <p:cNvPr id="44" name="Image 3" descr="preencoded.png"/>
+          <p:cNvPr id="42" name="Image 3" descr="preencoded.png">    </p:cNvPr>
           <p:cNvPicPr>
             <a:picLocks noChangeAspect="1"/>
           </p:cNvPicPr>
           <p:nvPr/>
         </p:nvPicPr>
         <p:blipFill>
-          <a:blip r:embed="rId6"/>
+          <a:blip r:embed="rId4"/>
           <a:stretch>
             <a:fillRect/>
           </a:stretch>
@@ -12623,7 +12868,7 @@
       </p:pic>
       <p:sp>
         <p:nvSpPr>
-          <p:cNvPr id="45" name="Text 39"/>
+          <p:cNvPr id="43" name="Text 37"/>
           <p:cNvSpPr txBox="1"/>
           <p:nvPr/>
         </p:nvSpPr>
@@ -12642,7 +12887,7 @@
           <a:bodyPr wrap="square" lIns="0" tIns="0" rIns="0" bIns="0" rtlCol="0" anchor="t"/>
           <a:lstStyle/>
           <a:p>
-            <a:pPr marL="0" indent="0">
+            <a:pPr indent="0" marL="0">
               <a:buNone/>
             </a:pPr>
             <a:r>
@@ -12662,7 +12907,7 @@
       </p:sp>
       <p:sp>
         <p:nvSpPr>
-          <p:cNvPr id="46" name="Text 40"/>
+          <p:cNvPr id="44" name="Text 38"/>
           <p:cNvSpPr txBox="1"/>
           <p:nvPr/>
         </p:nvSpPr>
@@ -12681,7 +12926,7 @@
           <a:bodyPr wrap="square" lIns="0" tIns="0" rIns="0" bIns="0" rtlCol="0" anchor="t"/>
           <a:lstStyle/>
           <a:p>
-            <a:pPr marL="0" indent="0">
+            <a:pPr indent="0" marL="0">
               <a:buNone/>
             </a:pPr>
             <a:r>
@@ -12701,7 +12946,7 @@
       </p:sp>
       <p:sp>
         <p:nvSpPr>
-          <p:cNvPr id="47" name="Shape 41"/>
+          <p:cNvPr id="45" name="Shape 39"/>
           <p:cNvSpPr/>
           <p:nvPr/>
         </p:nvSpPr>
@@ -12726,14 +12971,14 @@
       </p:sp>
       <p:pic>
         <p:nvPicPr>
-          <p:cNvPr id="48" name="Image 4" descr="preencoded.png"/>
+          <p:cNvPr id="46" name="Image 4" descr="preencoded.png">    </p:cNvPr>
           <p:cNvPicPr>
             <a:picLocks noChangeAspect="1"/>
           </p:cNvPicPr>
           <p:nvPr/>
         </p:nvPicPr>
         <p:blipFill>
-          <a:blip r:embed="rId7"/>
+          <a:blip r:embed="rId5"/>
           <a:stretch>
             <a:fillRect/>
           </a:stretch>
@@ -12750,7 +12995,7 @@
       </p:pic>
       <p:sp>
         <p:nvSpPr>
-          <p:cNvPr id="49" name="Text 42"/>
+          <p:cNvPr id="47" name="Text 40"/>
           <p:cNvSpPr txBox="1"/>
           <p:nvPr/>
         </p:nvSpPr>
@@ -12769,7 +13014,7 @@
           <a:bodyPr wrap="square" lIns="0" tIns="0" rIns="0" bIns="0" rtlCol="0" anchor="t"/>
           <a:lstStyle/>
           <a:p>
-            <a:pPr marL="0" indent="0">
+            <a:pPr indent="0" marL="0">
               <a:buNone/>
             </a:pPr>
             <a:r>
@@ -12789,7 +13034,7 @@
       </p:sp>
       <p:sp>
         <p:nvSpPr>
-          <p:cNvPr id="50" name="Text 43"/>
+          <p:cNvPr id="48" name="Text 41"/>
           <p:cNvSpPr txBox="1"/>
           <p:nvPr/>
         </p:nvSpPr>
@@ -12808,7 +13053,7 @@
           <a:bodyPr wrap="square" lIns="0" tIns="0" rIns="0" bIns="0" rtlCol="0" anchor="t"/>
           <a:lstStyle/>
           <a:p>
-            <a:pPr marL="0" indent="0">
+            <a:pPr indent="0" marL="0">
               <a:buNone/>
             </a:pPr>
             <a:r>
@@ -12828,7 +13073,7 @@
       </p:sp>
       <p:sp>
         <p:nvSpPr>
-          <p:cNvPr id="51" name="Shape 44"/>
+          <p:cNvPr id="49" name="Shape 42"/>
           <p:cNvSpPr/>
           <p:nvPr/>
         </p:nvSpPr>
@@ -12853,14 +13098,14 @@
       </p:sp>
       <p:pic>
         <p:nvPicPr>
-          <p:cNvPr id="52" name="Image 5" descr="preencoded.png"/>
+          <p:cNvPr id="50" name="Image 5" descr="preencoded.png">    </p:cNvPr>
           <p:cNvPicPr>
             <a:picLocks noChangeAspect="1"/>
           </p:cNvPicPr>
           <p:nvPr/>
         </p:nvPicPr>
         <p:blipFill>
-          <a:blip r:embed="rId8"/>
+          <a:blip r:embed="rId6"/>
           <a:stretch>
             <a:fillRect/>
           </a:stretch>
@@ -12877,7 +13122,7 @@
       </p:pic>
       <p:sp>
         <p:nvSpPr>
-          <p:cNvPr id="53" name="Text 45"/>
+          <p:cNvPr id="51" name="Text 43"/>
           <p:cNvSpPr txBox="1"/>
           <p:nvPr/>
         </p:nvSpPr>
@@ -12896,7 +13141,7 @@
           <a:bodyPr wrap="square" lIns="0" tIns="0" rIns="0" bIns="0" rtlCol="0" anchor="t"/>
           <a:lstStyle/>
           <a:p>
-            <a:pPr marL="0" indent="0">
+            <a:pPr indent="0" marL="0">
               <a:buNone/>
             </a:pPr>
             <a:r>
@@ -12916,7 +13161,7 @@
       </p:sp>
       <p:sp>
         <p:nvSpPr>
-          <p:cNvPr id="54" name="Text 46"/>
+          <p:cNvPr id="52" name="Text 44"/>
           <p:cNvSpPr txBox="1"/>
           <p:nvPr/>
         </p:nvSpPr>
@@ -12935,7 +13180,7 @@
           <a:bodyPr wrap="square" lIns="0" tIns="0" rIns="0" bIns="0" rtlCol="0" anchor="t"/>
           <a:lstStyle/>
           <a:p>
-            <a:pPr marL="0" indent="0">
+            <a:pPr indent="0" marL="0">
               <a:buNone/>
             </a:pPr>
             <a:r>
@@ -12955,7 +13200,7 @@
       </p:sp>
       <p:sp>
         <p:nvSpPr>
-          <p:cNvPr id="55" name="Shape 47"/>
+          <p:cNvPr id="53" name="Shape 45"/>
           <p:cNvSpPr/>
           <p:nvPr/>
         </p:nvSpPr>
@@ -12980,14 +13225,14 @@
       </p:sp>
       <p:pic>
         <p:nvPicPr>
-          <p:cNvPr id="56" name="Image 6" descr="preencoded.png"/>
+          <p:cNvPr id="54" name="Image 6" descr="preencoded.png">    </p:cNvPr>
           <p:cNvPicPr>
             <a:picLocks noChangeAspect="1"/>
           </p:cNvPicPr>
           <p:nvPr/>
         </p:nvPicPr>
         <p:blipFill>
-          <a:blip r:embed="rId9"/>
+          <a:blip r:embed="rId7"/>
           <a:stretch>
             <a:fillRect/>
           </a:stretch>
@@ -13004,7 +13249,7 @@
       </p:pic>
       <p:sp>
         <p:nvSpPr>
-          <p:cNvPr id="57" name="Text 48"/>
+          <p:cNvPr id="55" name="Text 46"/>
           <p:cNvSpPr txBox="1"/>
           <p:nvPr/>
         </p:nvSpPr>
@@ -13023,7 +13268,7 @@
           <a:bodyPr wrap="square" lIns="0" tIns="0" rIns="0" bIns="0" rtlCol="0" anchor="t"/>
           <a:lstStyle/>
           <a:p>
-            <a:pPr marL="0" indent="0">
+            <a:pPr indent="0" marL="0">
               <a:buNone/>
             </a:pPr>
             <a:r>
@@ -13043,7 +13288,7 @@
       </p:sp>
       <p:sp>
         <p:nvSpPr>
-          <p:cNvPr id="58" name="Text 49"/>
+          <p:cNvPr id="56" name="Text 47"/>
           <p:cNvSpPr txBox="1"/>
           <p:nvPr/>
         </p:nvSpPr>
@@ -13062,7 +13307,7 @@
           <a:bodyPr wrap="square" lIns="0" tIns="0" rIns="0" bIns="0" rtlCol="0" anchor="t"/>
           <a:lstStyle/>
           <a:p>
-            <a:pPr marL="0" indent="0">
+            <a:pPr indent="0" marL="0">
               <a:buNone/>
             </a:pPr>
             <a:r>
@@ -13077,6 +13322,45 @@
               <a:t>사진 리포트로 정리</a:t>
             </a:r>
             <a:endParaRPr lang="en-US" sz="1100" dirty="0"/>
+          </a:p>
+        </p:txBody>
+      </p:sp>
+      <p:sp>
+        <p:nvSpPr>
+          <p:cNvPr id="57" name="Text 48"/>
+          <p:cNvSpPr txBox="1"/>
+          <p:nvPr/>
+        </p:nvSpPr>
+        <p:spPr>
+          <a:xfrm>
+            <a:off x="6507328" y="5733288"/>
+            <a:ext cx="4952848" cy="228600"/>
+          </a:xfrm>
+          <a:prstGeom prst="rect">
+            <a:avLst/>
+          </a:prstGeom>
+          <a:noFill/>
+          <a:ln/>
+        </p:spPr>
+        <p:txBody>
+          <a:bodyPr wrap="square" lIns="0" tIns="0" rIns="0" bIns="0" rtlCol="0" anchor="t"/>
+          <a:lstStyle/>
+          <a:p>
+            <a:pPr indent="0" marL="0">
+              <a:buNone/>
+            </a:pPr>
+            <a:r>
+              <a:rPr lang="en-US" sz="1000" i="1" dirty="0">
+                <a:solidFill>
+                  <a:srgbClr val="A3A7AD"/>
+                </a:solidFill>
+                <a:latin typeface="맑은 고딕" pitchFamily="34" charset="0"/>
+                <a:ea typeface="맑은 고딕" pitchFamily="34" charset="-122"/>
+                <a:cs typeface="맑은 고딕" pitchFamily="34" charset="-120"/>
+              </a:rPr>
+              <a:t>미국 현장 인터뷰 (Deepwater · MISTRAS · Brown Corrosion 등)</a:t>
+            </a:r>
+            <a:endParaRPr lang="en-US" sz="1000" dirty="0"/>
           </a:p>
         </p:txBody>
       </p:sp>
@@ -13090,7 +13374,7 @@
 
 <file path=ppt/slides/slide9.xml><?xml version="1.0" encoding="utf-8"?>
 <p:sld xmlns:a="http://schemas.openxmlformats.org/drawingml/2006/main" xmlns:r="http://schemas.openxmlformats.org/officeDocument/2006/relationships" xmlns:p="http://schemas.openxmlformats.org/presentationml/2006/main">
-  <p:cSld name="Slide 1">
+  <p:cSld name="Slide 2">
     <p:bg>
       <p:bgPr>
         <a:solidFill>
@@ -13184,7 +13468,7 @@
                 <a:ea typeface="맑은 고딕" pitchFamily="34" charset="-122"/>
                 <a:cs typeface="맑은 고딕" pitchFamily="34" charset="-120"/>
               </a:rPr>
-              <a:t>시장 규모</a:t>
+              <a:t>시장 규모 (국내)</a:t>
             </a:r>
             <a:endParaRPr lang="en-US" sz="2800" dirty="0"/>
           </a:p>
@@ -13276,20 +13560,669 @@
         </p:nvSpPr>
         <p:spPr>
           <a:xfrm>
-            <a:off x="548640" y="1508760"/>
-            <a:ext cx="7040880" cy="1188720"/>
-          </a:xfrm>
-          <a:prstGeom prst="roundRect">
-            <a:avLst>
-              <a:gd name="adj" fmla="val 7692"/>
-            </a:avLst>
+            <a:off x="6492240" y="1508760"/>
+            <a:ext cx="4663440" cy="4663440"/>
+          </a:xfrm>
+          <a:prstGeom prst="ellipse">
+            <a:avLst/>
+          </a:prstGeom>
+          <a:solidFill>
+            <a:srgbClr val="B5501F"/>
+          </a:solidFill>
+          <a:ln w="31750">
+            <a:solidFill>
+              <a:srgbClr val="FFFFFF"/>
+            </a:solidFill>
+            <a:prstDash val="solid"/>
+          </a:ln>
+        </p:spPr>
+      </p:sp>
+      <p:sp>
+        <p:nvSpPr>
+          <p:cNvPr id="7" name="Shape 5"/>
+          <p:cNvSpPr/>
+          <p:nvPr/>
+        </p:nvSpPr>
+        <p:spPr>
+          <a:xfrm>
+            <a:off x="7246620" y="3017520"/>
+            <a:ext cx="3154680" cy="3154680"/>
+          </a:xfrm>
+          <a:prstGeom prst="ellipse">
+            <a:avLst/>
+          </a:prstGeom>
+          <a:solidFill>
+            <a:srgbClr val="E8A87C"/>
+          </a:solidFill>
+          <a:ln w="31750">
+            <a:solidFill>
+              <a:srgbClr val="FFFFFF"/>
+            </a:solidFill>
+            <a:prstDash val="solid"/>
+          </a:ln>
+        </p:spPr>
+      </p:sp>
+      <p:sp>
+        <p:nvSpPr>
+          <p:cNvPr id="8" name="Shape 6"/>
+          <p:cNvSpPr/>
+          <p:nvPr/>
+        </p:nvSpPr>
+        <p:spPr>
+          <a:xfrm>
+            <a:off x="7932420" y="4389120"/>
+            <a:ext cx="1783080" cy="1783080"/>
+          </a:xfrm>
+          <a:prstGeom prst="ellipse">
+            <a:avLst/>
+          </a:prstGeom>
+          <a:solidFill>
+            <a:srgbClr val="FFFFFF"/>
+          </a:solidFill>
+          <a:ln w="31750">
+            <a:solidFill>
+              <a:srgbClr val="FFFFFF"/>
+            </a:solidFill>
+            <a:prstDash val="solid"/>
+          </a:ln>
+        </p:spPr>
+      </p:sp>
+      <p:sp>
+        <p:nvSpPr>
+          <p:cNvPr id="9" name="Text 7"/>
+          <p:cNvSpPr txBox="1"/>
+          <p:nvPr/>
+        </p:nvSpPr>
+        <p:spPr>
+          <a:xfrm>
+            <a:off x="7543800" y="1783080"/>
+            <a:ext cx="2560320" cy="777240"/>
+          </a:xfrm>
+          <a:prstGeom prst="rect">
+            <a:avLst/>
+          </a:prstGeom>
+          <a:noFill/>
+          <a:ln/>
+        </p:spPr>
+        <p:txBody>
+          <a:bodyPr wrap="square" lIns="0" tIns="0" rIns="0" bIns="0" rtlCol="0" anchor="ctr"/>
+          <a:lstStyle/>
+          <a:p>
+            <a:pPr algn="ctr" indent="0" marL="0">
+              <a:buNone/>
+            </a:pPr>
+            <a:r>
+              <a:rPr lang="en-US" sz="2000" b="1" dirty="0">
+                <a:solidFill>
+                  <a:srgbClr val="FFFFFF"/>
+                </a:solidFill>
+                <a:latin typeface="맑은 고딕" pitchFamily="34" charset="0"/>
+                <a:ea typeface="맑은 고딕" pitchFamily="34" charset="-122"/>
+                <a:cs typeface="맑은 고딕" pitchFamily="34" charset="-120"/>
+              </a:rPr>
+              <a:t>TAM</a:t>
+            </a:r>
+            <a:endParaRPr lang="en-US" sz="1400" dirty="0"/>
+          </a:p>
+          <a:p>
+            <a:pPr algn="ctr" indent="0" marL="0">
+              <a:buNone/>
+            </a:pPr>
+            <a:r>
+              <a:rPr lang="en-US" sz="2200" b="1" dirty="0">
+                <a:solidFill>
+                  <a:srgbClr val="FFFFFF"/>
+                </a:solidFill>
+                <a:latin typeface="맑은 고딕" pitchFamily="34" charset="0"/>
+                <a:ea typeface="맑은 고딕" pitchFamily="34" charset="-122"/>
+                <a:cs typeface="맑은 고딕" pitchFamily="34" charset="-120"/>
+              </a:rPr>
+              <a:t>5,192억 원</a:t>
+            </a:r>
+            <a:endParaRPr lang="en-US" sz="1400" dirty="0"/>
+          </a:p>
+        </p:txBody>
+      </p:sp>
+      <p:sp>
+        <p:nvSpPr>
+          <p:cNvPr id="10" name="Text 8"/>
+          <p:cNvSpPr txBox="1"/>
+          <p:nvPr/>
+        </p:nvSpPr>
+        <p:spPr>
+          <a:xfrm>
+            <a:off x="7543800" y="3246120"/>
+            <a:ext cx="2560320" cy="777240"/>
+          </a:xfrm>
+          <a:prstGeom prst="rect">
+            <a:avLst/>
+          </a:prstGeom>
+          <a:noFill/>
+          <a:ln/>
+        </p:spPr>
+        <p:txBody>
+          <a:bodyPr wrap="square" lIns="0" tIns="0" rIns="0" bIns="0" rtlCol="0" anchor="ctr"/>
+          <a:lstStyle/>
+          <a:p>
+            <a:pPr algn="ctr" indent="0" marL="0">
+              <a:buNone/>
+            </a:pPr>
+            <a:r>
+              <a:rPr lang="en-US" sz="1800" b="1" dirty="0">
+                <a:solidFill>
+                  <a:srgbClr val="FFFFFF"/>
+                </a:solidFill>
+                <a:latin typeface="맑은 고딕" pitchFamily="34" charset="0"/>
+                <a:ea typeface="맑은 고딕" pitchFamily="34" charset="-122"/>
+                <a:cs typeface="맑은 고딕" pitchFamily="34" charset="-120"/>
+              </a:rPr>
+              <a:t>SAM</a:t>
+            </a:r>
+            <a:endParaRPr lang="en-US" sz="1400" dirty="0"/>
+          </a:p>
+          <a:p>
+            <a:pPr algn="ctr" indent="0" marL="0">
+              <a:buNone/>
+            </a:pPr>
+            <a:r>
+              <a:rPr lang="en-US" sz="1900" b="1" dirty="0">
+                <a:solidFill>
+                  <a:srgbClr val="FFFFFF"/>
+                </a:solidFill>
+                <a:latin typeface="맑은 고딕" pitchFamily="34" charset="0"/>
+                <a:ea typeface="맑은 고딕" pitchFamily="34" charset="-122"/>
+                <a:cs typeface="맑은 고딕" pitchFamily="34" charset="-120"/>
+              </a:rPr>
+              <a:t>1,667억 원</a:t>
+            </a:r>
+            <a:endParaRPr lang="en-US" sz="1400" dirty="0"/>
+          </a:p>
+        </p:txBody>
+      </p:sp>
+      <p:sp>
+        <p:nvSpPr>
+          <p:cNvPr id="11" name="Text 9"/>
+          <p:cNvSpPr txBox="1"/>
+          <p:nvPr/>
+        </p:nvSpPr>
+        <p:spPr>
+          <a:xfrm>
+            <a:off x="7543800" y="4896612"/>
+            <a:ext cx="2560320" cy="777240"/>
+          </a:xfrm>
+          <a:prstGeom prst="rect">
+            <a:avLst/>
+          </a:prstGeom>
+          <a:noFill/>
+          <a:ln/>
+        </p:spPr>
+        <p:txBody>
+          <a:bodyPr wrap="square" lIns="0" tIns="0" rIns="0" bIns="0" rtlCol="0" anchor="ctr"/>
+          <a:lstStyle/>
+          <a:p>
+            <a:pPr algn="ctr" indent="0" marL="0">
+              <a:buNone/>
+            </a:pPr>
+            <a:r>
+              <a:rPr lang="en-US" sz="1600" b="1" dirty="0">
+                <a:solidFill>
+                  <a:srgbClr val="B5501F"/>
+                </a:solidFill>
+                <a:latin typeface="맑은 고딕" pitchFamily="34" charset="0"/>
+                <a:ea typeface="맑은 고딕" pitchFamily="34" charset="-122"/>
+                <a:cs typeface="맑은 고딕" pitchFamily="34" charset="-120"/>
+              </a:rPr>
+              <a:t>SOM</a:t>
+            </a:r>
+            <a:endParaRPr lang="en-US" sz="1400" dirty="0"/>
+          </a:p>
+          <a:p>
+            <a:pPr algn="ctr" indent="0" marL="0">
+              <a:buNone/>
+            </a:pPr>
+            <a:r>
+              <a:rPr lang="en-US" sz="1600" b="1" dirty="0">
+                <a:solidFill>
+                  <a:srgbClr val="B5501F"/>
+                </a:solidFill>
+                <a:latin typeface="맑은 고딕" pitchFamily="34" charset="0"/>
+                <a:ea typeface="맑은 고딕" pitchFamily="34" charset="-122"/>
+                <a:cs typeface="맑은 고딕" pitchFamily="34" charset="-120"/>
+              </a:rPr>
+              <a:t>17억 원</a:t>
+            </a:r>
+            <a:endParaRPr lang="en-US" sz="1400" dirty="0"/>
+          </a:p>
+        </p:txBody>
+      </p:sp>
+      <p:sp>
+        <p:nvSpPr>
+          <p:cNvPr id="12" name="Shape 10"/>
+          <p:cNvSpPr/>
+          <p:nvPr/>
+        </p:nvSpPr>
+        <p:spPr>
+          <a:xfrm>
+            <a:off x="548640" y="1618488"/>
+            <a:ext cx="329184" cy="329184"/>
+          </a:xfrm>
+          <a:prstGeom prst="ellipse">
+            <a:avLst/>
+          </a:prstGeom>
+          <a:solidFill>
+            <a:srgbClr val="B5501F"/>
+          </a:solidFill>
+          <a:ln w="19050">
+            <a:solidFill>
+              <a:srgbClr val="FFFFFF"/>
+            </a:solidFill>
+            <a:prstDash val="solid"/>
+          </a:ln>
+        </p:spPr>
+      </p:sp>
+      <p:sp>
+        <p:nvSpPr>
+          <p:cNvPr id="13" name="Text 11"/>
+          <p:cNvSpPr txBox="1"/>
+          <p:nvPr/>
+        </p:nvSpPr>
+        <p:spPr>
+          <a:xfrm>
+            <a:off x="1005840" y="1563624"/>
+            <a:ext cx="4937760" cy="411480"/>
+          </a:xfrm>
+          <a:prstGeom prst="rect">
+            <a:avLst/>
+          </a:prstGeom>
+          <a:noFill/>
+          <a:ln/>
+        </p:spPr>
+        <p:txBody>
+          <a:bodyPr wrap="square" lIns="0" tIns="0" rIns="0" bIns="0" rtlCol="0" anchor="ctr"/>
+          <a:lstStyle/>
+          <a:p>
+            <a:pPr indent="0" marL="0">
+              <a:buNone/>
+            </a:pPr>
+            <a:r>
+              <a:rPr lang="en-US" sz="2000" b="1" dirty="0">
+                <a:solidFill>
+                  <a:srgbClr val="2B2D31"/>
+                </a:solidFill>
+                <a:latin typeface="맑은 고딕" pitchFamily="34" charset="0"/>
+                <a:ea typeface="맑은 고딕" pitchFamily="34" charset="-122"/>
+                <a:cs typeface="맑은 고딕" pitchFamily="34" charset="-120"/>
+              </a:rPr>
+              <a:t>TAM  5,192억 원</a:t>
+            </a:r>
+            <a:endParaRPr lang="en-US" sz="2000" dirty="0"/>
+          </a:p>
+        </p:txBody>
+      </p:sp>
+      <p:sp>
+        <p:nvSpPr>
+          <p:cNvPr id="14" name="Shape 12"/>
+          <p:cNvSpPr/>
+          <p:nvPr/>
+        </p:nvSpPr>
+        <p:spPr>
+          <a:xfrm>
+            <a:off x="3749040" y="1783080"/>
+            <a:ext cx="3703320" cy="384048"/>
+          </a:xfrm>
+          <a:prstGeom prst="line">
+            <a:avLst/>
+          </a:prstGeom>
+          <a:noFill/>
+          <a:ln w="15875">
+            <a:solidFill>
+              <a:srgbClr val="B5501F"/>
+            </a:solidFill>
+            <a:prstDash val="dash"/>
+          </a:ln>
+        </p:spPr>
+      </p:sp>
+      <p:sp>
+        <p:nvSpPr>
+          <p:cNvPr id="15" name="Text 13"/>
+          <p:cNvSpPr txBox="1"/>
+          <p:nvPr/>
+        </p:nvSpPr>
+        <p:spPr>
+          <a:xfrm>
+            <a:off x="1005840" y="2011680"/>
+            <a:ext cx="4480560" cy="274320"/>
+          </a:xfrm>
+          <a:prstGeom prst="rect">
+            <a:avLst/>
+          </a:prstGeom>
+          <a:noFill/>
+          <a:ln/>
+        </p:spPr>
+        <p:txBody>
+          <a:bodyPr wrap="square" lIns="0" tIns="0" rIns="0" bIns="0" rtlCol="0" anchor="t"/>
+          <a:lstStyle/>
+          <a:p>
+            <a:pPr indent="0" marL="0">
+              <a:buNone/>
+            </a:pPr>
+            <a:r>
+              <a:rPr lang="en-US" sz="1300" dirty="0">
+                <a:solidFill>
+                  <a:srgbClr val="2B2D31"/>
+                </a:solidFill>
+                <a:latin typeface="맑은 고딕" pitchFamily="34" charset="0"/>
+                <a:ea typeface="맑은 고딕" pitchFamily="34" charset="-122"/>
+                <a:cs typeface="맑은 고딕" pitchFamily="34" charset="-120"/>
+              </a:rPr>
+              <a:t>시설물 안전점검 · 진단 시장</a:t>
+            </a:r>
+            <a:endParaRPr lang="en-US" sz="1300" dirty="0"/>
+          </a:p>
+        </p:txBody>
+      </p:sp>
+      <p:sp>
+        <p:nvSpPr>
+          <p:cNvPr id="16" name="Text 14"/>
+          <p:cNvSpPr txBox="1"/>
+          <p:nvPr/>
+        </p:nvSpPr>
+        <p:spPr>
+          <a:xfrm>
+            <a:off x="1005840" y="2295144"/>
+            <a:ext cx="4480560" cy="256032"/>
+          </a:xfrm>
+          <a:prstGeom prst="rect">
+            <a:avLst/>
+          </a:prstGeom>
+          <a:noFill/>
+          <a:ln/>
+        </p:spPr>
+        <p:txBody>
+          <a:bodyPr wrap="square" lIns="0" tIns="0" rIns="0" bIns="0" rtlCol="0" anchor="t"/>
+          <a:lstStyle/>
+          <a:p>
+            <a:pPr indent="0" marL="0">
+              <a:buNone/>
+            </a:pPr>
+            <a:r>
+              <a:rPr lang="en-US" sz="1200" b="1" dirty="0">
+                <a:solidFill>
+                  <a:srgbClr val="B5501F"/>
+                </a:solidFill>
+                <a:latin typeface="맑은 고딕" pitchFamily="34" charset="0"/>
+                <a:ea typeface="맑은 고딕" pitchFamily="34" charset="-122"/>
+                <a:cs typeface="맑은 고딕" pitchFamily="34" charset="-120"/>
+              </a:rPr>
+              <a:t>연 15% 성장 ('17 → '21)</a:t>
+            </a:r>
+            <a:endParaRPr lang="en-US" sz="1200" dirty="0"/>
+          </a:p>
+        </p:txBody>
+      </p:sp>
+      <p:sp>
+        <p:nvSpPr>
+          <p:cNvPr id="17" name="Text 15"/>
+          <p:cNvSpPr txBox="1"/>
+          <p:nvPr/>
+        </p:nvSpPr>
+        <p:spPr>
+          <a:xfrm>
+            <a:off x="1005840" y="2560320"/>
+            <a:ext cx="4480560" cy="256032"/>
+          </a:xfrm>
+          <a:prstGeom prst="rect">
+            <a:avLst/>
+          </a:prstGeom>
+          <a:noFill/>
+          <a:ln/>
+        </p:spPr>
+        <p:txBody>
+          <a:bodyPr wrap="square" lIns="0" tIns="0" rIns="0" bIns="0" rtlCol="0" anchor="t"/>
+          <a:lstStyle/>
+          <a:p>
+            <a:pPr indent="0" marL="0">
+              <a:buNone/>
+            </a:pPr>
+            <a:r>
+              <a:rPr lang="en-US" sz="950" i="1" dirty="0">
+                <a:solidFill>
+                  <a:srgbClr val="A3A7AD"/>
+                </a:solidFill>
+                <a:latin typeface="맑은 고딕" pitchFamily="34" charset="0"/>
+                <a:ea typeface="맑은 고딕" pitchFamily="34" charset="-122"/>
+                <a:cs typeface="맑은 고딕" pitchFamily="34" charset="-120"/>
+              </a:rPr>
+              <a:t>국토교통부 제5차 시설물 안전 및 유지관리 기본계획 (2021년 기준)</a:t>
+            </a:r>
+            <a:endParaRPr lang="en-US" sz="950" dirty="0"/>
+          </a:p>
+        </p:txBody>
+      </p:sp>
+      <p:sp>
+        <p:nvSpPr>
+          <p:cNvPr id="18" name="Shape 16"/>
+          <p:cNvSpPr/>
+          <p:nvPr/>
+        </p:nvSpPr>
+        <p:spPr>
+          <a:xfrm>
+            <a:off x="548640" y="3035808"/>
+            <a:ext cx="329184" cy="329184"/>
+          </a:xfrm>
+          <a:prstGeom prst="ellipse">
+            <a:avLst/>
+          </a:prstGeom>
+          <a:solidFill>
+            <a:srgbClr val="E8A87C"/>
+          </a:solidFill>
+          <a:ln w="19050">
+            <a:solidFill>
+              <a:srgbClr val="FFFFFF"/>
+            </a:solidFill>
+            <a:prstDash val="solid"/>
+          </a:ln>
+        </p:spPr>
+      </p:sp>
+      <p:sp>
+        <p:nvSpPr>
+          <p:cNvPr id="19" name="Text 17"/>
+          <p:cNvSpPr txBox="1"/>
+          <p:nvPr/>
+        </p:nvSpPr>
+        <p:spPr>
+          <a:xfrm>
+            <a:off x="1005840" y="2980944"/>
+            <a:ext cx="4937760" cy="411480"/>
+          </a:xfrm>
+          <a:prstGeom prst="rect">
+            <a:avLst/>
+          </a:prstGeom>
+          <a:noFill/>
+          <a:ln/>
+        </p:spPr>
+        <p:txBody>
+          <a:bodyPr wrap="square" lIns="0" tIns="0" rIns="0" bIns="0" rtlCol="0" anchor="ctr"/>
+          <a:lstStyle/>
+          <a:p>
+            <a:pPr indent="0" marL="0">
+              <a:buNone/>
+            </a:pPr>
+            <a:r>
+              <a:rPr lang="en-US" sz="2000" b="1" dirty="0">
+                <a:solidFill>
+                  <a:srgbClr val="2B2D31"/>
+                </a:solidFill>
+                <a:latin typeface="맑은 고딕" pitchFamily="34" charset="0"/>
+                <a:ea typeface="맑은 고딕" pitchFamily="34" charset="-122"/>
+                <a:cs typeface="맑은 고딕" pitchFamily="34" charset="-120"/>
+              </a:rPr>
+              <a:t>SAM  1,667억 원</a:t>
+            </a:r>
+            <a:endParaRPr lang="en-US" sz="2000" dirty="0"/>
+          </a:p>
+        </p:txBody>
+      </p:sp>
+      <p:sp>
+        <p:nvSpPr>
+          <p:cNvPr id="20" name="Shape 18"/>
+          <p:cNvSpPr/>
+          <p:nvPr/>
+        </p:nvSpPr>
+        <p:spPr>
+          <a:xfrm>
+            <a:off x="3749040" y="3200400"/>
+            <a:ext cx="3703320" cy="429768"/>
+          </a:xfrm>
+          <a:prstGeom prst="line">
+            <a:avLst/>
+          </a:prstGeom>
+          <a:noFill/>
+          <a:ln w="15875">
+            <a:solidFill>
+              <a:srgbClr val="E8A87C"/>
+            </a:solidFill>
+            <a:prstDash val="dash"/>
+          </a:ln>
+        </p:spPr>
+      </p:sp>
+      <p:sp>
+        <p:nvSpPr>
+          <p:cNvPr id="21" name="Text 19"/>
+          <p:cNvSpPr txBox="1"/>
+          <p:nvPr/>
+        </p:nvSpPr>
+        <p:spPr>
+          <a:xfrm>
+            <a:off x="1005840" y="3429000"/>
+            <a:ext cx="4480560" cy="274320"/>
+          </a:xfrm>
+          <a:prstGeom prst="rect">
+            <a:avLst/>
+          </a:prstGeom>
+          <a:noFill/>
+          <a:ln/>
+        </p:spPr>
+        <p:txBody>
+          <a:bodyPr wrap="square" lIns="0" tIns="0" rIns="0" bIns="0" rtlCol="0" anchor="t"/>
+          <a:lstStyle/>
+          <a:p>
+            <a:pPr indent="0" marL="0">
+              <a:buNone/>
+            </a:pPr>
+            <a:r>
+              <a:rPr lang="en-US" sz="1300" dirty="0">
+                <a:solidFill>
+                  <a:srgbClr val="2B2D31"/>
+                </a:solidFill>
+                <a:latin typeface="맑은 고딕" pitchFamily="34" charset="0"/>
+                <a:ea typeface="맑은 고딕" pitchFamily="34" charset="-122"/>
+                <a:cs typeface="맑은 고딕" pitchFamily="34" charset="-120"/>
+              </a:rPr>
+              <a:t>드론 측량 · 점검 · 관측 시장</a:t>
+            </a:r>
+            <a:endParaRPr lang="en-US" sz="1300" dirty="0"/>
+          </a:p>
+        </p:txBody>
+      </p:sp>
+      <p:sp>
+        <p:nvSpPr>
+          <p:cNvPr id="22" name="Text 20"/>
+          <p:cNvSpPr txBox="1"/>
+          <p:nvPr/>
+        </p:nvSpPr>
+        <p:spPr>
+          <a:xfrm>
+            <a:off x="1005840" y="3712464"/>
+            <a:ext cx="4480560" cy="256032"/>
+          </a:xfrm>
+          <a:prstGeom prst="rect">
+            <a:avLst/>
+          </a:prstGeom>
+          <a:noFill/>
+          <a:ln/>
+        </p:spPr>
+        <p:txBody>
+          <a:bodyPr wrap="square" lIns="0" tIns="0" rIns="0" bIns="0" rtlCol="0" anchor="t"/>
+          <a:lstStyle/>
+          <a:p>
+            <a:pPr indent="0" marL="0">
+              <a:buNone/>
+            </a:pPr>
+            <a:r>
+              <a:rPr lang="en-US" sz="1200" b="1" dirty="0">
+                <a:solidFill>
+                  <a:srgbClr val="B5501F"/>
+                </a:solidFill>
+                <a:latin typeface="맑은 고딕" pitchFamily="34" charset="0"/>
+                <a:ea typeface="맑은 고딕" pitchFamily="34" charset="-122"/>
+                <a:cs typeface="맑은 고딕" pitchFamily="34" charset="-120"/>
+              </a:rPr>
+              <a:t>드론 활용 분야 중 26%</a:t>
+            </a:r>
+            <a:endParaRPr lang="en-US" sz="1200" dirty="0"/>
+          </a:p>
+        </p:txBody>
+      </p:sp>
+      <p:sp>
+        <p:nvSpPr>
+          <p:cNvPr id="23" name="Text 21"/>
+          <p:cNvSpPr txBox="1"/>
+          <p:nvPr/>
+        </p:nvSpPr>
+        <p:spPr>
+          <a:xfrm>
+            <a:off x="1005840" y="3977640"/>
+            <a:ext cx="4480560" cy="256032"/>
+          </a:xfrm>
+          <a:prstGeom prst="rect">
+            <a:avLst/>
+          </a:prstGeom>
+          <a:noFill/>
+          <a:ln/>
+        </p:spPr>
+        <p:txBody>
+          <a:bodyPr wrap="square" lIns="0" tIns="0" rIns="0" bIns="0" rtlCol="0" anchor="t"/>
+          <a:lstStyle/>
+          <a:p>
+            <a:pPr indent="0" marL="0">
+              <a:buNone/>
+            </a:pPr>
+            <a:r>
+              <a:rPr lang="en-US" sz="950" i="1" dirty="0">
+                <a:solidFill>
+                  <a:srgbClr val="A3A7AD"/>
+                </a:solidFill>
+                <a:latin typeface="맑은 고딕" pitchFamily="34" charset="0"/>
+                <a:ea typeface="맑은 고딕" pitchFamily="34" charset="-122"/>
+                <a:cs typeface="맑은 고딕" pitchFamily="34" charset="-120"/>
+              </a:rPr>
+              <a:t>드론정보포털 활용업체 시장 통계</a:t>
+            </a:r>
+            <a:endParaRPr lang="en-US" sz="950" dirty="0"/>
+          </a:p>
+        </p:txBody>
+      </p:sp>
+      <p:sp>
+        <p:nvSpPr>
+          <p:cNvPr id="24" name="Shape 22"/>
+          <p:cNvSpPr/>
+          <p:nvPr/>
+        </p:nvSpPr>
+        <p:spPr>
+          <a:xfrm>
+            <a:off x="548640" y="4453128"/>
+            <a:ext cx="329184" cy="329184"/>
+          </a:xfrm>
+          <a:prstGeom prst="ellipse">
+            <a:avLst/>
           </a:prstGeom>
           <a:solidFill>
             <a:srgbClr val="2B2D31"/>
           </a:solidFill>
-          <a:ln w="12700">
+          <a:ln w="19050">
             <a:solidFill>
-              <a:srgbClr val="2B2D31"/>
+              <a:srgbClr val="FFFFFF"/>
             </a:solidFill>
             <a:prstDash val="solid"/>
           </a:ln>
@@ -13297,14 +14230,14 @@
       </p:sp>
       <p:sp>
         <p:nvSpPr>
-          <p:cNvPr id="7" name="Text 5"/>
-          <p:cNvSpPr txBox="1"/>
-          <p:nvPr/>
-        </p:nvSpPr>
-        <p:spPr>
-          <a:xfrm>
-            <a:off x="822960" y="1508760"/>
-            <a:ext cx="914400" cy="1188720"/>
+          <p:cNvPr id="25" name="Text 23"/>
+          <p:cNvSpPr txBox="1"/>
+          <p:nvPr/>
+        </p:nvSpPr>
+        <p:spPr>
+          <a:xfrm>
+            <a:off x="1005840" y="4398264"/>
+            <a:ext cx="4937760" cy="411480"/>
           </a:xfrm>
           <a:prstGeom prst="rect">
             <a:avLst/>
@@ -13320,86 +14253,131 @@
               <a:buNone/>
             </a:pPr>
             <a:r>
-              <a:rPr lang="en-US" sz="2200" b="1" dirty="0">
-                <a:solidFill>
-                  <a:srgbClr val="FFFFFF"/>
-                </a:solidFill>
-                <a:latin typeface="맑은 고딕" pitchFamily="34" charset="0"/>
-                <a:ea typeface="맑은 고딕" pitchFamily="34" charset="-122"/>
-                <a:cs typeface="맑은 고딕" pitchFamily="34" charset="-120"/>
-              </a:rPr>
-              <a:t>TAM</a:t>
-            </a:r>
-            <a:endParaRPr lang="en-US" sz="2200" dirty="0"/>
-          </a:p>
-        </p:txBody>
-      </p:sp>
-      <p:sp>
-        <p:nvSpPr>
-          <p:cNvPr id="8" name="Text 6"/>
-          <p:cNvSpPr txBox="1"/>
-          <p:nvPr/>
-        </p:nvSpPr>
-        <p:spPr>
-          <a:xfrm>
-            <a:off x="1783080" y="1600200"/>
-            <a:ext cx="5669280" cy="868680"/>
-          </a:xfrm>
-          <a:prstGeom prst="rect">
-            <a:avLst/>
-          </a:prstGeom>
-          <a:noFill/>
-          <a:ln/>
-        </p:spPr>
-        <p:txBody>
-          <a:bodyPr wrap="square" lIns="0" tIns="0" rIns="0" bIns="0" rtlCol="0" anchor="ctr"/>
+              <a:rPr lang="en-US" sz="2000" b="1" dirty="0">
+                <a:solidFill>
+                  <a:srgbClr val="2B2D31"/>
+                </a:solidFill>
+                <a:latin typeface="맑은 고딕" pitchFamily="34" charset="0"/>
+                <a:ea typeface="맑은 고딕" pitchFamily="34" charset="-122"/>
+                <a:cs typeface="맑은 고딕" pitchFamily="34" charset="-120"/>
+              </a:rPr>
+              <a:t>SOM  17억 원</a:t>
+            </a:r>
+            <a:endParaRPr lang="en-US" sz="2000" dirty="0"/>
+          </a:p>
+        </p:txBody>
+      </p:sp>
+      <p:sp>
+        <p:nvSpPr>
+          <p:cNvPr id="26" name="Shape 24"/>
+          <p:cNvSpPr/>
+          <p:nvPr/>
+        </p:nvSpPr>
+        <p:spPr>
+          <a:xfrm>
+            <a:off x="3749040" y="4617720"/>
+            <a:ext cx="3703320" cy="662940"/>
+          </a:xfrm>
+          <a:prstGeom prst="line">
+            <a:avLst/>
+          </a:prstGeom>
+          <a:noFill/>
+          <a:ln w="15875">
+            <a:solidFill>
+              <a:srgbClr val="A3A7AD"/>
+            </a:solidFill>
+            <a:prstDash val="dash"/>
+          </a:ln>
+        </p:spPr>
+      </p:sp>
+      <p:sp>
+        <p:nvSpPr>
+          <p:cNvPr id="27" name="Text 25"/>
+          <p:cNvSpPr txBox="1"/>
+          <p:nvPr/>
+        </p:nvSpPr>
+        <p:spPr>
+          <a:xfrm>
+            <a:off x="1005840" y="4846320"/>
+            <a:ext cx="4480560" cy="274320"/>
+          </a:xfrm>
+          <a:prstGeom prst="rect">
+            <a:avLst/>
+          </a:prstGeom>
+          <a:noFill/>
+          <a:ln/>
+        </p:spPr>
+        <p:txBody>
+          <a:bodyPr wrap="square" lIns="0" tIns="0" rIns="0" bIns="0" rtlCol="0" anchor="t"/>
           <a:lstStyle/>
           <a:p>
             <a:pPr indent="0" marL="0">
               <a:buNone/>
             </a:pPr>
             <a:r>
-              <a:rPr lang="en-US" sz="1250" dirty="0">
-                <a:solidFill>
-                  <a:srgbClr val="E6E8EB"/>
-                </a:solidFill>
-                <a:latin typeface="맑은 고딕" pitchFamily="34" charset="0"/>
-                <a:ea typeface="맑은 고딕" pitchFamily="34" charset="-122"/>
-                <a:cs typeface="맑은 고딕" pitchFamily="34" charset="-120"/>
-              </a:rPr>
-              <a:t>글로벌 해양 점검 · 보수 · 유지(IRM) 시장</a:t>
-            </a:r>
-            <a:endParaRPr lang="en-US" sz="1400" dirty="0"/>
-          </a:p>
+              <a:rPr lang="en-US" sz="1300" dirty="0">
+                <a:solidFill>
+                  <a:srgbClr val="2B2D31"/>
+                </a:solidFill>
+                <a:latin typeface="맑은 고딕" pitchFamily="34" charset="0"/>
+                <a:ea typeface="맑은 고딕" pitchFamily="34" charset="-122"/>
+                <a:cs typeface="맑은 고딕" pitchFamily="34" charset="-120"/>
+              </a:rPr>
+              <a:t>3년 내 목표: SAM의 1%</a:t>
+            </a:r>
+            <a:endParaRPr lang="en-US" sz="1300" dirty="0"/>
+          </a:p>
+        </p:txBody>
+      </p:sp>
+      <p:sp>
+        <p:nvSpPr>
+          <p:cNvPr id="28" name="Text 26"/>
+          <p:cNvSpPr txBox="1"/>
+          <p:nvPr/>
+        </p:nvSpPr>
+        <p:spPr>
+          <a:xfrm>
+            <a:off x="1005840" y="5129784"/>
+            <a:ext cx="4480560" cy="256032"/>
+          </a:xfrm>
+          <a:prstGeom prst="rect">
+            <a:avLst/>
+          </a:prstGeom>
+          <a:noFill/>
+          <a:ln/>
+        </p:spPr>
+        <p:txBody>
+          <a:bodyPr wrap="square" lIns="0" tIns="0" rIns="0" bIns="0" rtlCol="0" anchor="t"/>
+          <a:lstStyle/>
           <a:p>
             <a:pPr indent="0" marL="0">
               <a:buNone/>
             </a:pPr>
             <a:r>
-              <a:rPr lang="en-US" sz="2600" b="1" dirty="0">
-                <a:solidFill>
-                  <a:srgbClr val="FFFFFF"/>
-                </a:solidFill>
-                <a:latin typeface="맑은 고딕" pitchFamily="34" charset="0"/>
-                <a:ea typeface="맑은 고딕" pitchFamily="34" charset="-122"/>
-                <a:cs typeface="맑은 고딕" pitchFamily="34" charset="-120"/>
-              </a:rPr>
-              <a:t>136억 달러</a:t>
-            </a:r>
-            <a:endParaRPr lang="en-US" sz="1400" dirty="0"/>
-          </a:p>
-        </p:txBody>
-      </p:sp>
-      <p:sp>
-        <p:nvSpPr>
-          <p:cNvPr id="9" name="Text 7"/>
-          <p:cNvSpPr txBox="1"/>
-          <p:nvPr/>
-        </p:nvSpPr>
-        <p:spPr>
-          <a:xfrm>
-            <a:off x="1783080" y="2395728"/>
-            <a:ext cx="5669280" cy="228600"/>
+              <a:rPr lang="en-US" sz="1200" b="1" dirty="0">
+                <a:solidFill>
+                  <a:srgbClr val="B5501F"/>
+                </a:solidFill>
+                <a:latin typeface="맑은 고딕" pitchFamily="34" charset="0"/>
+                <a:ea typeface="맑은 고딕" pitchFamily="34" charset="-122"/>
+                <a:cs typeface="맑은 고딕" pitchFamily="34" charset="-120"/>
+              </a:rPr>
+              <a:t>해양 · 항만 강구조물 · 해상풍력부터</a:t>
+            </a:r>
+            <a:endParaRPr lang="en-US" sz="1200" dirty="0"/>
+          </a:p>
+        </p:txBody>
+      </p:sp>
+      <p:sp>
+        <p:nvSpPr>
+          <p:cNvPr id="29" name="Text 27"/>
+          <p:cNvSpPr txBox="1"/>
+          <p:nvPr/>
+        </p:nvSpPr>
+        <p:spPr>
+          <a:xfrm>
+            <a:off x="1005840" y="5394960"/>
+            <a:ext cx="4480560" cy="256032"/>
           </a:xfrm>
           <a:prstGeom prst="rect">
             <a:avLst/>
@@ -13417,894 +14395,15 @@
             <a:r>
               <a:rPr lang="en-US" sz="950" i="1" dirty="0">
                 <a:solidFill>
-                  <a:srgbClr val="D5D7DA"/>
-                </a:solidFill>
-                <a:latin typeface="맑은 고딕" pitchFamily="34" charset="0"/>
-                <a:ea typeface="맑은 고딕" pitchFamily="34" charset="-122"/>
-                <a:cs typeface="맑은 고딕" pitchFamily="34" charset="-120"/>
-              </a:rPr>
-              <a:t>Research and Markets (2024)</a:t>
+                  <a:srgbClr val="A3A7AD"/>
+                </a:solidFill>
+                <a:latin typeface="맑은 고딕" pitchFamily="34" charset="0"/>
+                <a:ea typeface="맑은 고딕" pitchFamily="34" charset="-122"/>
+                <a:cs typeface="맑은 고딕" pitchFamily="34" charset="-120"/>
+              </a:rPr>
+              <a:t>MLC 목표 (가정)</a:t>
             </a:r>
             <a:endParaRPr lang="en-US" sz="950" dirty="0"/>
-          </a:p>
-        </p:txBody>
-      </p:sp>
-      <p:sp>
-        <p:nvSpPr>
-          <p:cNvPr id="10" name="Shape 8"/>
-          <p:cNvSpPr/>
-          <p:nvPr/>
-        </p:nvSpPr>
-        <p:spPr>
-          <a:xfrm>
-            <a:off x="1323137" y="2898648"/>
-            <a:ext cx="5491886" cy="1188720"/>
-          </a:xfrm>
-          <a:prstGeom prst="roundRect">
-            <a:avLst>
-              <a:gd name="adj" fmla="val 7692"/>
-            </a:avLst>
-          </a:prstGeom>
-          <a:solidFill>
-            <a:srgbClr val="1F5F7A"/>
-          </a:solidFill>
-          <a:ln w="12700">
-            <a:solidFill>
-              <a:srgbClr val="1F5F7A"/>
-            </a:solidFill>
-            <a:prstDash val="solid"/>
-          </a:ln>
-        </p:spPr>
-      </p:sp>
-      <p:sp>
-        <p:nvSpPr>
-          <p:cNvPr id="11" name="Text 9"/>
-          <p:cNvSpPr txBox="1"/>
-          <p:nvPr/>
-        </p:nvSpPr>
-        <p:spPr>
-          <a:xfrm>
-            <a:off x="1597457" y="2898648"/>
-            <a:ext cx="914400" cy="1188720"/>
-          </a:xfrm>
-          <a:prstGeom prst="rect">
-            <a:avLst/>
-          </a:prstGeom>
-          <a:noFill/>
-          <a:ln/>
-        </p:spPr>
-        <p:txBody>
-          <a:bodyPr wrap="square" lIns="0" tIns="0" rIns="0" bIns="0" rtlCol="0" anchor="ctr"/>
-          <a:lstStyle/>
-          <a:p>
-            <a:pPr indent="0" marL="0">
-              <a:buNone/>
-            </a:pPr>
-            <a:r>
-              <a:rPr lang="en-US" sz="2200" b="1" dirty="0">
-                <a:solidFill>
-                  <a:srgbClr val="FFFFFF"/>
-                </a:solidFill>
-                <a:latin typeface="맑은 고딕" pitchFamily="34" charset="0"/>
-                <a:ea typeface="맑은 고딕" pitchFamily="34" charset="-122"/>
-                <a:cs typeface="맑은 고딕" pitchFamily="34" charset="-120"/>
-              </a:rPr>
-              <a:t>SAM</a:t>
-            </a:r>
-            <a:endParaRPr lang="en-US" sz="2200" dirty="0"/>
-          </a:p>
-        </p:txBody>
-      </p:sp>
-      <p:sp>
-        <p:nvSpPr>
-          <p:cNvPr id="12" name="Text 10"/>
-          <p:cNvSpPr txBox="1"/>
-          <p:nvPr/>
-        </p:nvSpPr>
-        <p:spPr>
-          <a:xfrm>
-            <a:off x="2557577" y="2990088"/>
-            <a:ext cx="4120286" cy="868680"/>
-          </a:xfrm>
-          <a:prstGeom prst="rect">
-            <a:avLst/>
-          </a:prstGeom>
-          <a:noFill/>
-          <a:ln/>
-        </p:spPr>
-        <p:txBody>
-          <a:bodyPr wrap="square" lIns="0" tIns="0" rIns="0" bIns="0" rtlCol="0" anchor="ctr"/>
-          <a:lstStyle/>
-          <a:p>
-            <a:pPr indent="0" marL="0">
-              <a:buNone/>
-            </a:pPr>
-            <a:r>
-              <a:rPr lang="en-US" sz="1250" dirty="0">
-                <a:solidFill>
-                  <a:srgbClr val="E6E8EB"/>
-                </a:solidFill>
-                <a:latin typeface="맑은 고딕" pitchFamily="34" charset="0"/>
-                <a:ea typeface="맑은 고딕" pitchFamily="34" charset="-122"/>
-                <a:cs typeface="맑은 고딕" pitchFamily="34" charset="-120"/>
-              </a:rPr>
-              <a:t>해양 드론 점검 서비스 시장</a:t>
-            </a:r>
-            <a:endParaRPr lang="en-US" sz="1400" dirty="0"/>
-          </a:p>
-          <a:p>
-            <a:pPr indent="0" marL="0">
-              <a:buNone/>
-            </a:pPr>
-            <a:r>
-              <a:rPr lang="en-US" sz="2600" b="1" dirty="0">
-                <a:solidFill>
-                  <a:srgbClr val="FFFFFF"/>
-                </a:solidFill>
-                <a:latin typeface="맑은 고딕" pitchFamily="34" charset="0"/>
-                <a:ea typeface="맑은 고딕" pitchFamily="34" charset="-122"/>
-                <a:cs typeface="맑은 고딕" pitchFamily="34" charset="-120"/>
-              </a:rPr>
-              <a:t>15억 달러</a:t>
-            </a:r>
-            <a:endParaRPr lang="en-US" sz="1400" dirty="0"/>
-          </a:p>
-        </p:txBody>
-      </p:sp>
-      <p:sp>
-        <p:nvSpPr>
-          <p:cNvPr id="13" name="Text 11"/>
-          <p:cNvSpPr txBox="1"/>
-          <p:nvPr/>
-        </p:nvSpPr>
-        <p:spPr>
-          <a:xfrm>
-            <a:off x="2557577" y="3785616"/>
-            <a:ext cx="4120286" cy="228600"/>
-          </a:xfrm>
-          <a:prstGeom prst="rect">
-            <a:avLst/>
-          </a:prstGeom>
-          <a:noFill/>
-          <a:ln/>
-        </p:spPr>
-        <p:txBody>
-          <a:bodyPr wrap="square" lIns="0" tIns="0" rIns="0" bIns="0" rtlCol="0" anchor="t"/>
-          <a:lstStyle/>
-          <a:p>
-            <a:pPr indent="0" marL="0">
-              <a:buNone/>
-            </a:pPr>
-            <a:r>
-              <a:rPr lang="en-US" sz="950" i="1" dirty="0">
-                <a:solidFill>
-                  <a:srgbClr val="D5D7DA"/>
-                </a:solidFill>
-                <a:latin typeface="맑은 고딕" pitchFamily="34" charset="0"/>
-                <a:ea typeface="맑은 고딕" pitchFamily="34" charset="-122"/>
-                <a:cs typeface="맑은 고딕" pitchFamily="34" charset="-120"/>
-              </a:rPr>
-              <a:t>Exactitude Consultancy (2024)</a:t>
-            </a:r>
-            <a:endParaRPr lang="en-US" sz="950" dirty="0"/>
-          </a:p>
-        </p:txBody>
-      </p:sp>
-      <p:sp>
-        <p:nvSpPr>
-          <p:cNvPr id="14" name="Shape 12"/>
-          <p:cNvSpPr/>
-          <p:nvPr/>
-        </p:nvSpPr>
-        <p:spPr>
-          <a:xfrm>
-            <a:off x="2097634" y="4288536"/>
-            <a:ext cx="3942893" cy="1188720"/>
-          </a:xfrm>
-          <a:prstGeom prst="roundRect">
-            <a:avLst>
-              <a:gd name="adj" fmla="val 7692"/>
-            </a:avLst>
-          </a:prstGeom>
-          <a:solidFill>
-            <a:srgbClr val="B5501F"/>
-          </a:solidFill>
-          <a:ln w="12700">
-            <a:solidFill>
-              <a:srgbClr val="B5501F"/>
-            </a:solidFill>
-            <a:prstDash val="solid"/>
-          </a:ln>
-        </p:spPr>
-      </p:sp>
-      <p:sp>
-        <p:nvSpPr>
-          <p:cNvPr id="15" name="Text 13"/>
-          <p:cNvSpPr txBox="1"/>
-          <p:nvPr/>
-        </p:nvSpPr>
-        <p:spPr>
-          <a:xfrm>
-            <a:off x="2371954" y="4288536"/>
-            <a:ext cx="914400" cy="1188720"/>
-          </a:xfrm>
-          <a:prstGeom prst="rect">
-            <a:avLst/>
-          </a:prstGeom>
-          <a:noFill/>
-          <a:ln/>
-        </p:spPr>
-        <p:txBody>
-          <a:bodyPr wrap="square" lIns="0" tIns="0" rIns="0" bIns="0" rtlCol="0" anchor="ctr"/>
-          <a:lstStyle/>
-          <a:p>
-            <a:pPr indent="0" marL="0">
-              <a:buNone/>
-            </a:pPr>
-            <a:r>
-              <a:rPr lang="en-US" sz="2200" b="1" dirty="0">
-                <a:solidFill>
-                  <a:srgbClr val="FFFFFF"/>
-                </a:solidFill>
-                <a:latin typeface="맑은 고딕" pitchFamily="34" charset="0"/>
-                <a:ea typeface="맑은 고딕" pitchFamily="34" charset="-122"/>
-                <a:cs typeface="맑은 고딕" pitchFamily="34" charset="-120"/>
-              </a:rPr>
-              <a:t>SOM</a:t>
-            </a:r>
-            <a:endParaRPr lang="en-US" sz="2200" dirty="0"/>
-          </a:p>
-        </p:txBody>
-      </p:sp>
-      <p:sp>
-        <p:nvSpPr>
-          <p:cNvPr id="16" name="Text 14"/>
-          <p:cNvSpPr txBox="1"/>
-          <p:nvPr/>
-        </p:nvSpPr>
-        <p:spPr>
-          <a:xfrm>
-            <a:off x="3332074" y="4379976"/>
-            <a:ext cx="2571293" cy="868680"/>
-          </a:xfrm>
-          <a:prstGeom prst="rect">
-            <a:avLst/>
-          </a:prstGeom>
-          <a:noFill/>
-          <a:ln/>
-        </p:spPr>
-        <p:txBody>
-          <a:bodyPr wrap="square" lIns="0" tIns="0" rIns="0" bIns="0" rtlCol="0" anchor="ctr"/>
-          <a:lstStyle/>
-          <a:p>
-            <a:pPr indent="0" marL="0">
-              <a:buNone/>
-            </a:pPr>
-            <a:r>
-              <a:rPr lang="en-US" sz="1250" dirty="0">
-                <a:solidFill>
-                  <a:srgbClr val="E6E8EB"/>
-                </a:solidFill>
-                <a:latin typeface="맑은 고딕" pitchFamily="34" charset="0"/>
-                <a:ea typeface="맑은 고딕" pitchFamily="34" charset="-122"/>
-                <a:cs typeface="맑은 고딕" pitchFamily="34" charset="-120"/>
-              </a:rPr>
-              <a:t>3년 내 목표: SAM의 1%</a:t>
-            </a:r>
-            <a:endParaRPr lang="en-US" sz="1400" dirty="0"/>
-          </a:p>
-          <a:p>
-            <a:pPr indent="0" marL="0">
-              <a:buNone/>
-            </a:pPr>
-            <a:r>
-              <a:rPr lang="en-US" sz="2600" b="1" dirty="0">
-                <a:solidFill>
-                  <a:srgbClr val="FFFFFF"/>
-                </a:solidFill>
-                <a:latin typeface="맑은 고딕" pitchFamily="34" charset="0"/>
-                <a:ea typeface="맑은 고딕" pitchFamily="34" charset="-122"/>
-                <a:cs typeface="맑은 고딕" pitchFamily="34" charset="-120"/>
-              </a:rPr>
-              <a:t>1,500만 달러</a:t>
-            </a:r>
-            <a:endParaRPr lang="en-US" sz="1400" dirty="0"/>
-          </a:p>
-        </p:txBody>
-      </p:sp>
-      <p:sp>
-        <p:nvSpPr>
-          <p:cNvPr id="17" name="Text 15"/>
-          <p:cNvSpPr txBox="1"/>
-          <p:nvPr/>
-        </p:nvSpPr>
-        <p:spPr>
-          <a:xfrm>
-            <a:off x="3332074" y="5175504"/>
-            <a:ext cx="2571293" cy="228600"/>
-          </a:xfrm>
-          <a:prstGeom prst="rect">
-            <a:avLst/>
-          </a:prstGeom>
-          <a:noFill/>
-          <a:ln/>
-        </p:spPr>
-        <p:txBody>
-          <a:bodyPr wrap="square" lIns="0" tIns="0" rIns="0" bIns="0" rtlCol="0" anchor="t"/>
-          <a:lstStyle/>
-          <a:p>
-            <a:pPr indent="0" marL="0">
-              <a:buNone/>
-            </a:pPr>
-            <a:r>
-              <a:rPr lang="en-US" sz="950" i="1" dirty="0">
-                <a:solidFill>
-                  <a:srgbClr val="D5D7DA"/>
-                </a:solidFill>
-                <a:latin typeface="맑은 고딕" pitchFamily="34" charset="0"/>
-                <a:ea typeface="맑은 고딕" pitchFamily="34" charset="-122"/>
-                <a:cs typeface="맑은 고딕" pitchFamily="34" charset="-120"/>
-              </a:rPr>
-              <a:t>MLC 목표 (가정)</a:t>
-            </a:r>
-            <a:endParaRPr lang="en-US" sz="950" dirty="0"/>
-          </a:p>
-        </p:txBody>
-      </p:sp>
-      <p:sp>
-        <p:nvSpPr>
-          <p:cNvPr id="18" name="Text 16"/>
-          <p:cNvSpPr txBox="1"/>
-          <p:nvPr/>
-        </p:nvSpPr>
-        <p:spPr>
-          <a:xfrm>
-            <a:off x="8001000" y="1508760"/>
-            <a:ext cx="3642055" cy="274320"/>
-          </a:xfrm>
-          <a:prstGeom prst="rect">
-            <a:avLst/>
-          </a:prstGeom>
-          <a:noFill/>
-          <a:ln/>
-        </p:spPr>
-        <p:txBody>
-          <a:bodyPr wrap="square" lIns="0" tIns="0" rIns="0" bIns="0" rtlCol="0" anchor="t"/>
-          <a:lstStyle/>
-          <a:p>
-            <a:pPr indent="0" marL="0">
-              <a:buNone/>
-            </a:pPr>
-            <a:r>
-              <a:rPr lang="en-US" sz="1300" b="1" dirty="0">
-                <a:solidFill>
-                  <a:srgbClr val="1F5F7A"/>
-                </a:solidFill>
-                <a:latin typeface="맑은 고딕" pitchFamily="34" charset="0"/>
-                <a:ea typeface="맑은 고딕" pitchFamily="34" charset="-122"/>
-                <a:cs typeface="맑은 고딕" pitchFamily="34" charset="-120"/>
-              </a:rPr>
-              <a:t>성장성</a:t>
-            </a:r>
-            <a:endParaRPr lang="en-US" sz="1300" dirty="0"/>
-          </a:p>
-        </p:txBody>
-      </p:sp>
-      <p:sp>
-        <p:nvSpPr>
-          <p:cNvPr id="19" name="Shape 17"/>
-          <p:cNvSpPr/>
-          <p:nvPr/>
-        </p:nvSpPr>
-        <p:spPr>
-          <a:xfrm>
-            <a:off x="8001000" y="1874520"/>
-            <a:ext cx="3642055" cy="896112"/>
-          </a:xfrm>
-          <a:prstGeom prst="roundRect">
-            <a:avLst>
-              <a:gd name="adj" fmla="val 8163"/>
-            </a:avLst>
-          </a:prstGeom>
-          <a:solidFill>
-            <a:srgbClr val="F3F4F6"/>
-          </a:solidFill>
-          <a:ln w="12700">
-            <a:solidFill>
-              <a:srgbClr val="F3F4F6"/>
-            </a:solidFill>
-            <a:prstDash val="solid"/>
-          </a:ln>
-        </p:spPr>
-      </p:sp>
-      <p:sp>
-        <p:nvSpPr>
-          <p:cNvPr id="20" name="Shape 18"/>
-          <p:cNvSpPr/>
-          <p:nvPr/>
-        </p:nvSpPr>
-        <p:spPr>
-          <a:xfrm>
-            <a:off x="8183880" y="2057400"/>
-            <a:ext cx="530352" cy="530352"/>
-          </a:xfrm>
-          <a:prstGeom prst="ellipse">
-            <a:avLst/>
-          </a:prstGeom>
-          <a:solidFill>
-            <a:srgbClr val="2B2D31"/>
-          </a:solidFill>
-          <a:ln w="12700">
-            <a:solidFill>
-              <a:srgbClr val="2B2D31"/>
-            </a:solidFill>
-            <a:prstDash val="solid"/>
-          </a:ln>
-        </p:spPr>
-      </p:sp>
-      <p:pic>
-        <p:nvPicPr>
-          <p:cNvPr id="21" name="Image 0" descr="preencoded.png">    </p:cNvPr>
-          <p:cNvPicPr>
-            <a:picLocks noChangeAspect="1"/>
-          </p:cNvPicPr>
-          <p:nvPr/>
-        </p:nvPicPr>
-        <p:blipFill>
-          <a:blip r:embed="rId1"/>
-          <a:stretch>
-            <a:fillRect/>
-          </a:stretch>
-        </p:blipFill>
-        <p:spPr>
-          <a:xfrm>
-            <a:off x="8321772" y="2195292"/>
-            <a:ext cx="254569" cy="254569"/>
-          </a:xfrm>
-          <a:prstGeom prst="rect">
-            <a:avLst/>
-          </a:prstGeom>
-        </p:spPr>
-      </p:pic>
-      <p:sp>
-        <p:nvSpPr>
-          <p:cNvPr id="22" name="Text 19"/>
-          <p:cNvSpPr txBox="1"/>
-          <p:nvPr/>
-        </p:nvSpPr>
-        <p:spPr>
-          <a:xfrm>
-            <a:off x="8869680" y="1965960"/>
-            <a:ext cx="2636215" cy="411480"/>
-          </a:xfrm>
-          <a:prstGeom prst="rect">
-            <a:avLst/>
-          </a:prstGeom>
-          <a:noFill/>
-          <a:ln/>
-        </p:spPr>
-        <p:txBody>
-          <a:bodyPr wrap="square" lIns="0" tIns="0" rIns="0" bIns="0" rtlCol="0" anchor="ctr"/>
-          <a:lstStyle/>
-          <a:p>
-            <a:pPr indent="0" marL="0">
-              <a:buNone/>
-            </a:pPr>
-            <a:r>
-              <a:rPr lang="en-US" sz="2200" b="1" dirty="0">
-                <a:solidFill>
-                  <a:srgbClr val="2B2D31"/>
-                </a:solidFill>
-                <a:latin typeface="맑은 고딕" pitchFamily="34" charset="0"/>
-                <a:ea typeface="맑은 고딕" pitchFamily="34" charset="-122"/>
-                <a:cs typeface="맑은 고딕" pitchFamily="34" charset="-120"/>
-              </a:rPr>
-              <a:t>연 8.4%</a:t>
-            </a:r>
-            <a:endParaRPr lang="en-US" sz="2200" dirty="0"/>
-          </a:p>
-        </p:txBody>
-      </p:sp>
-      <p:sp>
-        <p:nvSpPr>
-          <p:cNvPr id="23" name="Text 20"/>
-          <p:cNvSpPr txBox="1"/>
-          <p:nvPr/>
-        </p:nvSpPr>
-        <p:spPr>
-          <a:xfrm>
-            <a:off x="8869680" y="2377440"/>
-            <a:ext cx="2636215" cy="274320"/>
-          </a:xfrm>
-          <a:prstGeom prst="rect">
-            <a:avLst/>
-          </a:prstGeom>
-          <a:noFill/>
-          <a:ln/>
-        </p:spPr>
-        <p:txBody>
-          <a:bodyPr wrap="square" lIns="0" tIns="0" rIns="0" bIns="0" rtlCol="0" anchor="t"/>
-          <a:lstStyle/>
-          <a:p>
-            <a:pPr indent="0" marL="0">
-              <a:buNone/>
-            </a:pPr>
-            <a:r>
-              <a:rPr lang="en-US" sz="1150" dirty="0">
-                <a:solidFill>
-                  <a:srgbClr val="6B6F76"/>
-                </a:solidFill>
-                <a:latin typeface="맑은 고딕" pitchFamily="34" charset="0"/>
-                <a:ea typeface="맑은 고딕" pitchFamily="34" charset="-122"/>
-                <a:cs typeface="맑은 고딕" pitchFamily="34" charset="-120"/>
-              </a:rPr>
-              <a:t>해양 IRM 시장 성장 (~2030)</a:t>
-            </a:r>
-            <a:endParaRPr lang="en-US" sz="1150" dirty="0"/>
-          </a:p>
-        </p:txBody>
-      </p:sp>
-      <p:sp>
-        <p:nvSpPr>
-          <p:cNvPr id="24" name="Shape 21"/>
-          <p:cNvSpPr/>
-          <p:nvPr/>
-        </p:nvSpPr>
-        <p:spPr>
-          <a:xfrm>
-            <a:off x="8001000" y="2898648"/>
-            <a:ext cx="3642055" cy="896112"/>
-          </a:xfrm>
-          <a:prstGeom prst="roundRect">
-            <a:avLst>
-              <a:gd name="adj" fmla="val 8163"/>
-            </a:avLst>
-          </a:prstGeom>
-          <a:solidFill>
-            <a:srgbClr val="F3F4F6"/>
-          </a:solidFill>
-          <a:ln w="12700">
-            <a:solidFill>
-              <a:srgbClr val="F3F4F6"/>
-            </a:solidFill>
-            <a:prstDash val="solid"/>
-          </a:ln>
-        </p:spPr>
-      </p:sp>
-      <p:sp>
-        <p:nvSpPr>
-          <p:cNvPr id="25" name="Shape 22"/>
-          <p:cNvSpPr/>
-          <p:nvPr/>
-        </p:nvSpPr>
-        <p:spPr>
-          <a:xfrm>
-            <a:off x="8183880" y="3081528"/>
-            <a:ext cx="530352" cy="530352"/>
-          </a:xfrm>
-          <a:prstGeom prst="ellipse">
-            <a:avLst/>
-          </a:prstGeom>
-          <a:solidFill>
-            <a:srgbClr val="1F5F7A"/>
-          </a:solidFill>
-          <a:ln w="12700">
-            <a:solidFill>
-              <a:srgbClr val="1F5F7A"/>
-            </a:solidFill>
-            <a:prstDash val="solid"/>
-          </a:ln>
-        </p:spPr>
-      </p:sp>
-      <p:pic>
-        <p:nvPicPr>
-          <p:cNvPr id="26" name="Image 1" descr="preencoded.png">    </p:cNvPr>
-          <p:cNvPicPr>
-            <a:picLocks noChangeAspect="1"/>
-          </p:cNvPicPr>
-          <p:nvPr/>
-        </p:nvPicPr>
-        <p:blipFill>
-          <a:blip r:embed="rId2"/>
-          <a:stretch>
-            <a:fillRect/>
-          </a:stretch>
-        </p:blipFill>
-        <p:spPr>
-          <a:xfrm>
-            <a:off x="8321772" y="3219420"/>
-            <a:ext cx="254569" cy="254569"/>
-          </a:xfrm>
-          <a:prstGeom prst="rect">
-            <a:avLst/>
-          </a:prstGeom>
-        </p:spPr>
-      </p:pic>
-      <p:sp>
-        <p:nvSpPr>
-          <p:cNvPr id="27" name="Text 23"/>
-          <p:cNvSpPr txBox="1"/>
-          <p:nvPr/>
-        </p:nvSpPr>
-        <p:spPr>
-          <a:xfrm>
-            <a:off x="8869680" y="2990088"/>
-            <a:ext cx="2636215" cy="411480"/>
-          </a:xfrm>
-          <a:prstGeom prst="rect">
-            <a:avLst/>
-          </a:prstGeom>
-          <a:noFill/>
-          <a:ln/>
-        </p:spPr>
-        <p:txBody>
-          <a:bodyPr wrap="square" lIns="0" tIns="0" rIns="0" bIns="0" rtlCol="0" anchor="ctr"/>
-          <a:lstStyle/>
-          <a:p>
-            <a:pPr indent="0" marL="0">
-              <a:buNone/>
-            </a:pPr>
-            <a:r>
-              <a:rPr lang="en-US" sz="2200" b="1" dirty="0">
-                <a:solidFill>
-                  <a:srgbClr val="1F5F7A"/>
-                </a:solidFill>
-                <a:latin typeface="맑은 고딕" pitchFamily="34" charset="0"/>
-                <a:ea typeface="맑은 고딕" pitchFamily="34" charset="-122"/>
-                <a:cs typeface="맑은 고딕" pitchFamily="34" charset="-120"/>
-              </a:rPr>
-              <a:t>연 11.5%</a:t>
-            </a:r>
-            <a:endParaRPr lang="en-US" sz="2200" dirty="0"/>
-          </a:p>
-        </p:txBody>
-      </p:sp>
-      <p:sp>
-        <p:nvSpPr>
-          <p:cNvPr id="28" name="Text 24"/>
-          <p:cNvSpPr txBox="1"/>
-          <p:nvPr/>
-        </p:nvSpPr>
-        <p:spPr>
-          <a:xfrm>
-            <a:off x="8869680" y="3401568"/>
-            <a:ext cx="2636215" cy="274320"/>
-          </a:xfrm>
-          <a:prstGeom prst="rect">
-            <a:avLst/>
-          </a:prstGeom>
-          <a:noFill/>
-          <a:ln/>
-        </p:spPr>
-        <p:txBody>
-          <a:bodyPr wrap="square" lIns="0" tIns="0" rIns="0" bIns="0" rtlCol="0" anchor="t"/>
-          <a:lstStyle/>
-          <a:p>
-            <a:pPr indent="0" marL="0">
-              <a:buNone/>
-            </a:pPr>
-            <a:r>
-              <a:rPr lang="en-US" sz="1150" dirty="0">
-                <a:solidFill>
-                  <a:srgbClr val="6B6F76"/>
-                </a:solidFill>
-                <a:latin typeface="맑은 고딕" pitchFamily="34" charset="0"/>
-                <a:ea typeface="맑은 고딕" pitchFamily="34" charset="-122"/>
-                <a:cs typeface="맑은 고딕" pitchFamily="34" charset="-120"/>
-              </a:rPr>
-              <a:t>해양 드론 점검 서비스 성장 (~2034)</a:t>
-            </a:r>
-            <a:endParaRPr lang="en-US" sz="1150" dirty="0"/>
-          </a:p>
-        </p:txBody>
-      </p:sp>
-      <p:sp>
-        <p:nvSpPr>
-          <p:cNvPr id="29" name="Text 25"/>
-          <p:cNvSpPr txBox="1"/>
-          <p:nvPr/>
-        </p:nvSpPr>
-        <p:spPr>
-          <a:xfrm>
-            <a:off x="8001000" y="4041648"/>
-            <a:ext cx="3642055" cy="274320"/>
-          </a:xfrm>
-          <a:prstGeom prst="rect">
-            <a:avLst/>
-          </a:prstGeom>
-          <a:noFill/>
-          <a:ln/>
-        </p:spPr>
-        <p:txBody>
-          <a:bodyPr wrap="square" lIns="0" tIns="0" rIns="0" bIns="0" rtlCol="0" anchor="t"/>
-          <a:lstStyle/>
-          <a:p>
-            <a:pPr indent="0" marL="0">
-              <a:buNone/>
-            </a:pPr>
-            <a:r>
-              <a:rPr lang="en-US" sz="1300" b="1" dirty="0">
-                <a:solidFill>
-                  <a:srgbClr val="B5501F"/>
-                </a:solidFill>
-                <a:latin typeface="맑은 고딕" pitchFamily="34" charset="0"/>
-                <a:ea typeface="맑은 고딕" pitchFamily="34" charset="-122"/>
-                <a:cs typeface="맑은 고딕" pitchFamily="34" charset="-120"/>
-              </a:rPr>
-              <a:t>첫 타깃</a:t>
-            </a:r>
-            <a:endParaRPr lang="en-US" sz="1300" dirty="0"/>
-          </a:p>
-        </p:txBody>
-      </p:sp>
-      <p:sp>
-        <p:nvSpPr>
-          <p:cNvPr id="30" name="Shape 26"/>
-          <p:cNvSpPr/>
-          <p:nvPr/>
-        </p:nvSpPr>
-        <p:spPr>
-          <a:xfrm>
-            <a:off x="8001000" y="4389120"/>
-            <a:ext cx="3642055" cy="1188720"/>
-          </a:xfrm>
-          <a:prstGeom prst="roundRect">
-            <a:avLst>
-              <a:gd name="adj" fmla="val 6154"/>
-            </a:avLst>
-          </a:prstGeom>
-          <a:solidFill>
-            <a:srgbClr val="FBEDE4"/>
-          </a:solidFill>
-          <a:ln w="12700">
-            <a:solidFill>
-              <a:srgbClr val="FBEDE4"/>
-            </a:solidFill>
-            <a:prstDash val="solid"/>
-          </a:ln>
-        </p:spPr>
-      </p:sp>
-      <p:sp>
-        <p:nvSpPr>
-          <p:cNvPr id="31" name="Shape 27"/>
-          <p:cNvSpPr/>
-          <p:nvPr/>
-        </p:nvSpPr>
-        <p:spPr>
-          <a:xfrm>
-            <a:off x="8183880" y="4572000"/>
-            <a:ext cx="530352" cy="530352"/>
-          </a:xfrm>
-          <a:prstGeom prst="ellipse">
-            <a:avLst/>
-          </a:prstGeom>
-          <a:solidFill>
-            <a:srgbClr val="B5501F"/>
-          </a:solidFill>
-          <a:ln w="12700">
-            <a:solidFill>
-              <a:srgbClr val="B5501F"/>
-            </a:solidFill>
-            <a:prstDash val="solid"/>
-          </a:ln>
-        </p:spPr>
-      </p:sp>
-      <p:pic>
-        <p:nvPicPr>
-          <p:cNvPr id="32" name="Image 2" descr="preencoded.png">    </p:cNvPr>
-          <p:cNvPicPr>
-            <a:picLocks noChangeAspect="1"/>
-          </p:cNvPicPr>
-          <p:nvPr/>
-        </p:nvPicPr>
-        <p:blipFill>
-          <a:blip r:embed="rId3"/>
-          <a:stretch>
-            <a:fillRect/>
-          </a:stretch>
-        </p:blipFill>
-        <p:spPr>
-          <a:xfrm>
-            <a:off x="8321772" y="4709892"/>
-            <a:ext cx="254569" cy="254569"/>
-          </a:xfrm>
-          <a:prstGeom prst="rect">
-            <a:avLst/>
-          </a:prstGeom>
-        </p:spPr>
-      </p:pic>
-      <p:sp>
-        <p:nvSpPr>
-          <p:cNvPr id="33" name="Text 28"/>
-          <p:cNvSpPr txBox="1"/>
-          <p:nvPr/>
-        </p:nvSpPr>
-        <p:spPr>
-          <a:xfrm>
-            <a:off x="8869680" y="4480560"/>
-            <a:ext cx="2636215" cy="457200"/>
-          </a:xfrm>
-          <a:prstGeom prst="rect">
-            <a:avLst/>
-          </a:prstGeom>
-          <a:noFill/>
-          <a:ln/>
-        </p:spPr>
-        <p:txBody>
-          <a:bodyPr wrap="square" lIns="0" tIns="0" rIns="0" bIns="0" rtlCol="0" anchor="ctr"/>
-          <a:lstStyle/>
-          <a:p>
-            <a:pPr indent="0" marL="0">
-              <a:buNone/>
-            </a:pPr>
-            <a:r>
-              <a:rPr lang="en-US" sz="2400" b="1" dirty="0">
-                <a:solidFill>
-                  <a:srgbClr val="B5501F"/>
-                </a:solidFill>
-                <a:latin typeface="맑은 고딕" pitchFamily="34" charset="0"/>
-                <a:ea typeface="맑은 고딕" pitchFamily="34" charset="-122"/>
-                <a:cs typeface="맑은 고딕" pitchFamily="34" charset="-120"/>
-              </a:rPr>
-              <a:t>371곳</a:t>
-            </a:r>
-            <a:endParaRPr lang="en-US" sz="2400" dirty="0"/>
-          </a:p>
-        </p:txBody>
-      </p:sp>
-      <p:sp>
-        <p:nvSpPr>
-          <p:cNvPr id="34" name="Text 29"/>
-          <p:cNvSpPr txBox="1"/>
-          <p:nvPr/>
-        </p:nvSpPr>
-        <p:spPr>
-          <a:xfrm>
-            <a:off x="8869680" y="4956048"/>
-            <a:ext cx="2636215" cy="566928"/>
-          </a:xfrm>
-          <a:prstGeom prst="rect">
-            <a:avLst/>
-          </a:prstGeom>
-          <a:noFill/>
-          <a:ln/>
-        </p:spPr>
-        <p:txBody>
-          <a:bodyPr wrap="square" lIns="0" tIns="0" rIns="0" bIns="0" rtlCol="0" anchor="t"/>
-          <a:lstStyle/>
-          <a:p>
-            <a:pPr indent="0" marL="0">
-              <a:buNone/>
-            </a:pPr>
-            <a:r>
-              <a:rPr lang="en-US" sz="1150" dirty="0">
-                <a:solidFill>
-                  <a:srgbClr val="2B2D31"/>
-                </a:solidFill>
-                <a:latin typeface="맑은 고딕" pitchFamily="34" charset="0"/>
-                <a:ea typeface="맑은 고딕" pitchFamily="34" charset="-122"/>
-                <a:cs typeface="맑은 고딕" pitchFamily="34" charset="-120"/>
-              </a:rPr>
-              <a:t>멕시코만 유인 생산 플랫폼</a:t>
-            </a:r>
-            <a:endParaRPr lang="en-US" sz="1150" dirty="0"/>
-          </a:p>
-          <a:p>
-            <a:pPr indent="0" marL="0">
-              <a:buNone/>
-            </a:pPr>
-            <a:r>
-              <a:rPr lang="en-US" sz="1150" dirty="0">
-                <a:solidFill>
-                  <a:srgbClr val="2B2D31"/>
-                </a:solidFill>
-                <a:latin typeface="맑은 고딕" pitchFamily="34" charset="0"/>
-                <a:ea typeface="맑은 고딕" pitchFamily="34" charset="-122"/>
-                <a:cs typeface="맑은 고딕" pitchFamily="34" charset="-120"/>
-              </a:rPr>
-              <a:t>매년 Level I 점검 대상 (BSEE, 2024)</a:t>
-            </a:r>
-            <a:endParaRPr lang="en-US" sz="1150" dirty="0"/>
           </a:p>
         </p:txBody>
       </p:sp>

</xml_diff>